<commit_message>
Devops RL CS2 ppts and CS4 combined
</commit_message>
<xml_diff>
--- a/Devops/Recorded Lectures/1426833_81212_ls1.3_v1_need for devops.pptx
+++ b/Devops/Recorded Lectures/1426833_81212_ls1.3_v1_need for devops.pptx
@@ -5,18 +5,15 @@
     <p:sldMasterId id="2147483726" r:id="rId1"/>
   </p:sldMasterIdLst>
   <p:sldIdLst>
-    <p:sldId id="266" r:id="rId2"/>
-    <p:sldId id="265" r:id="rId3"/>
-    <p:sldId id="270" r:id="rId4"/>
-    <p:sldId id="271" r:id="rId5"/>
-    <p:sldId id="269" r:id="rId6"/>
-    <p:sldId id="272" r:id="rId7"/>
-    <p:sldId id="273" r:id="rId8"/>
-    <p:sldId id="274" r:id="rId9"/>
-    <p:sldId id="275" r:id="rId10"/>
-    <p:sldId id="276" r:id="rId11"/>
-    <p:sldId id="277" r:id="rId12"/>
-    <p:sldId id="268" r:id="rId13"/>
+    <p:sldId id="270" r:id="rId2"/>
+    <p:sldId id="271" r:id="rId3"/>
+    <p:sldId id="269" r:id="rId4"/>
+    <p:sldId id="272" r:id="rId5"/>
+    <p:sldId id="273" r:id="rId6"/>
+    <p:sldId id="274" r:id="rId7"/>
+    <p:sldId id="275" r:id="rId8"/>
+    <p:sldId id="276" r:id="rId9"/>
+    <p:sldId id="277" r:id="rId10"/>
   </p:sldIdLst>
   <p:sldSz cx="12192000" cy="6858000"/>
   <p:notesSz cx="6858000" cy="9144000"/>
@@ -3997,13 +3994,6 @@
     <dgm:pt modelId="{6963F1A8-60BB-4158-9459-84B596FE2FFB}" type="pres">
       <dgm:prSet presAssocID="{363E9F57-9ED8-475A-8F74-A2F323174483}" presName="wedge1" presStyleLbl="node1" presStyleIdx="0" presStyleCnt="3" custLinFactNeighborX="-130" custLinFactNeighborY="-283"/>
       <dgm:spPr/>
-      <dgm:t>
-        <a:bodyPr/>
-        <a:lstStyle/>
-        <a:p>
-          <a:endParaRPr lang="en-US"/>
-        </a:p>
-      </dgm:t>
     </dgm:pt>
     <dgm:pt modelId="{A2A535E7-341B-4E0C-A4F7-57FE0493DE82}" type="pres">
       <dgm:prSet presAssocID="{363E9F57-9ED8-475A-8F74-A2F323174483}" presName="dummy1a" presStyleCnt="0"/>
@@ -4022,24 +4012,10 @@
         </dgm:presLayoutVars>
       </dgm:prSet>
       <dgm:spPr/>
-      <dgm:t>
-        <a:bodyPr/>
-        <a:lstStyle/>
-        <a:p>
-          <a:endParaRPr lang="en-US"/>
-        </a:p>
-      </dgm:t>
     </dgm:pt>
     <dgm:pt modelId="{1FAD7337-1A41-421E-BC31-1F834A8BC574}" type="pres">
       <dgm:prSet presAssocID="{363E9F57-9ED8-475A-8F74-A2F323174483}" presName="wedge2" presStyleLbl="node1" presStyleIdx="1" presStyleCnt="3" custScaleX="101001" custScaleY="97802"/>
       <dgm:spPr/>
-      <dgm:t>
-        <a:bodyPr/>
-        <a:lstStyle/>
-        <a:p>
-          <a:endParaRPr lang="en-US"/>
-        </a:p>
-      </dgm:t>
     </dgm:pt>
     <dgm:pt modelId="{1B25827D-7EE5-4BFB-9621-9B963D81A743}" type="pres">
       <dgm:prSet presAssocID="{363E9F57-9ED8-475A-8F74-A2F323174483}" presName="dummy2a" presStyleCnt="0"/>
@@ -4058,24 +4034,10 @@
         </dgm:presLayoutVars>
       </dgm:prSet>
       <dgm:spPr/>
-      <dgm:t>
-        <a:bodyPr/>
-        <a:lstStyle/>
-        <a:p>
-          <a:endParaRPr lang="en-US"/>
-        </a:p>
-      </dgm:t>
     </dgm:pt>
     <dgm:pt modelId="{7598C916-8694-41AB-BEB3-6466444FECA5}" type="pres">
       <dgm:prSet presAssocID="{363E9F57-9ED8-475A-8F74-A2F323174483}" presName="wedge3" presStyleLbl="node1" presStyleIdx="2" presStyleCnt="3"/>
       <dgm:spPr/>
-      <dgm:t>
-        <a:bodyPr/>
-        <a:lstStyle/>
-        <a:p>
-          <a:endParaRPr lang="en-US"/>
-        </a:p>
-      </dgm:t>
     </dgm:pt>
     <dgm:pt modelId="{EC35A7D7-CEFD-472B-A47B-F82670C3142E}" type="pres">
       <dgm:prSet presAssocID="{363E9F57-9ED8-475A-8F74-A2F323174483}" presName="dummy3a" presStyleCnt="0"/>
@@ -4094,13 +4056,6 @@
         </dgm:presLayoutVars>
       </dgm:prSet>
       <dgm:spPr/>
-      <dgm:t>
-        <a:bodyPr/>
-        <a:lstStyle/>
-        <a:p>
-          <a:endParaRPr lang="en-US"/>
-        </a:p>
-      </dgm:t>
     </dgm:pt>
     <dgm:pt modelId="{838AFCA9-556E-4FD4-8799-E04854472C0C}" type="pres">
       <dgm:prSet presAssocID="{2A967CC4-E967-486D-874E-0368636E9FDA}" presName="arrowWedge1" presStyleLbl="fgSibTrans2D1" presStyleIdx="0" presStyleCnt="3"/>
@@ -4116,16 +4071,16 @@
     </dgm:pt>
   </dgm:ptLst>
   <dgm:cxnLst>
-    <dgm:cxn modelId="{367760C6-924A-4369-A742-E7568E70B041}" type="presOf" srcId="{C4F2C712-035A-44B1-9871-6B611BDAB2DC}" destId="{299F1328-A7F0-4E5A-99DF-667E8CCCB418}" srcOrd="1" destOrd="0" presId="urn:microsoft.com/office/officeart/2005/8/layout/cycle8"/>
-    <dgm:cxn modelId="{9AE5B4A9-B2CE-4024-B7A5-C9DE2E1FEAB8}" type="presOf" srcId="{25647C8C-D1AC-48E2-946D-1E7B95E1CFC7}" destId="{1FAD7337-1A41-421E-BC31-1F834A8BC574}" srcOrd="0" destOrd="0" presId="urn:microsoft.com/office/officeart/2005/8/layout/cycle8"/>
-    <dgm:cxn modelId="{0A6FDAAA-6A53-4B5D-8B32-335BF4C4781E}" srcId="{363E9F57-9ED8-475A-8F74-A2F323174483}" destId="{25647C8C-D1AC-48E2-946D-1E7B95E1CFC7}" srcOrd="1" destOrd="0" parTransId="{2D6C8F49-A0DA-4C4C-8899-4081A24F6984}" sibTransId="{78910D3F-5B30-4DC6-94D7-8F0E71DCCC97}"/>
+    <dgm:cxn modelId="{B936D408-B958-49F4-B60C-D50151AE3BA8}" type="presOf" srcId="{A1CBFE2C-EA05-413A-8B58-1E71A0B6573E}" destId="{46783136-B3D5-478D-8F79-3A1F75BE85AB}" srcOrd="1" destOrd="0" presId="urn:microsoft.com/office/officeart/2005/8/layout/cycle8"/>
+    <dgm:cxn modelId="{9664A909-D19A-430B-A394-67DCA34B966C}" type="presOf" srcId="{25647C8C-D1AC-48E2-946D-1E7B95E1CFC7}" destId="{09A6FF26-F28B-447E-BD7C-CF8CBABD041B}" srcOrd="1" destOrd="0" presId="urn:microsoft.com/office/officeart/2005/8/layout/cycle8"/>
     <dgm:cxn modelId="{C3C39B1F-6117-4675-9EAD-8CDBBAFE62D1}" type="presOf" srcId="{363E9F57-9ED8-475A-8F74-A2F323174483}" destId="{8CA2298F-A522-474F-9730-A3F7C1C74AF5}" srcOrd="0" destOrd="0" presId="urn:microsoft.com/office/officeart/2005/8/layout/cycle8"/>
     <dgm:cxn modelId="{2F50B361-A9D9-4188-A681-FA4918D29F00}" srcId="{363E9F57-9ED8-475A-8F74-A2F323174483}" destId="{C4F2C712-035A-44B1-9871-6B611BDAB2DC}" srcOrd="2" destOrd="0" parTransId="{650CCF50-EE84-4354-BD61-C2B5A22ACB91}" sibTransId="{6387B9B0-C447-41D5-AC57-B4EF99CB01F7}"/>
     <dgm:cxn modelId="{9E275D76-AA00-407F-A0A6-C1B979A720C4}" type="presOf" srcId="{C4F2C712-035A-44B1-9871-6B611BDAB2DC}" destId="{7598C916-8694-41AB-BEB3-6466444FECA5}" srcOrd="0" destOrd="0" presId="urn:microsoft.com/office/officeart/2005/8/layout/cycle8"/>
+    <dgm:cxn modelId="{9AE5B4A9-B2CE-4024-B7A5-C9DE2E1FEAB8}" type="presOf" srcId="{25647C8C-D1AC-48E2-946D-1E7B95E1CFC7}" destId="{1FAD7337-1A41-421E-BC31-1F834A8BC574}" srcOrd="0" destOrd="0" presId="urn:microsoft.com/office/officeart/2005/8/layout/cycle8"/>
+    <dgm:cxn modelId="{0A6FDAAA-6A53-4B5D-8B32-335BF4C4781E}" srcId="{363E9F57-9ED8-475A-8F74-A2F323174483}" destId="{25647C8C-D1AC-48E2-946D-1E7B95E1CFC7}" srcOrd="1" destOrd="0" parTransId="{2D6C8F49-A0DA-4C4C-8899-4081A24F6984}" sibTransId="{78910D3F-5B30-4DC6-94D7-8F0E71DCCC97}"/>
+    <dgm:cxn modelId="{367760C6-924A-4369-A742-E7568E70B041}" type="presOf" srcId="{C4F2C712-035A-44B1-9871-6B611BDAB2DC}" destId="{299F1328-A7F0-4E5A-99DF-667E8CCCB418}" srcOrd="1" destOrd="0" presId="urn:microsoft.com/office/officeart/2005/8/layout/cycle8"/>
     <dgm:cxn modelId="{9EF681E1-0CA4-47E6-9748-F5F3003FE468}" type="presOf" srcId="{A1CBFE2C-EA05-413A-8B58-1E71A0B6573E}" destId="{6963F1A8-60BB-4158-9459-84B596FE2FFB}" srcOrd="0" destOrd="0" presId="urn:microsoft.com/office/officeart/2005/8/layout/cycle8"/>
-    <dgm:cxn modelId="{9664A909-D19A-430B-A394-67DCA34B966C}" type="presOf" srcId="{25647C8C-D1AC-48E2-946D-1E7B95E1CFC7}" destId="{09A6FF26-F28B-447E-BD7C-CF8CBABD041B}" srcOrd="1" destOrd="0" presId="urn:microsoft.com/office/officeart/2005/8/layout/cycle8"/>
     <dgm:cxn modelId="{19C03EEB-9AC0-47A2-8561-6DB9D0D04875}" srcId="{363E9F57-9ED8-475A-8F74-A2F323174483}" destId="{A1CBFE2C-EA05-413A-8B58-1E71A0B6573E}" srcOrd="0" destOrd="0" parTransId="{11B40467-40D7-48D1-8BBD-03CF7D8D262F}" sibTransId="{2A967CC4-E967-486D-874E-0368636E9FDA}"/>
-    <dgm:cxn modelId="{B936D408-B958-49F4-B60C-D50151AE3BA8}" type="presOf" srcId="{A1CBFE2C-EA05-413A-8B58-1E71A0B6573E}" destId="{46783136-B3D5-478D-8F79-3A1F75BE85AB}" srcOrd="1" destOrd="0" presId="urn:microsoft.com/office/officeart/2005/8/layout/cycle8"/>
     <dgm:cxn modelId="{324EB352-2C7E-4991-A1F2-9B3D33233BF1}" type="presParOf" srcId="{8CA2298F-A522-474F-9730-A3F7C1C74AF5}" destId="{6963F1A8-60BB-4158-9459-84B596FE2FFB}" srcOrd="0" destOrd="0" presId="urn:microsoft.com/office/officeart/2005/8/layout/cycle8"/>
     <dgm:cxn modelId="{48152C6D-E912-4EC8-B47A-3B71B8EF5763}" type="presParOf" srcId="{8CA2298F-A522-474F-9730-A3F7C1C74AF5}" destId="{A2A535E7-341B-4E0C-A4F7-57FE0493DE82}" srcOrd="1" destOrd="0" presId="urn:microsoft.com/office/officeart/2005/8/layout/cycle8"/>
     <dgm:cxn modelId="{C8498018-2557-40DA-B664-5B0A00ACF560}" type="presParOf" srcId="{8CA2298F-A522-474F-9730-A3F7C1C74AF5}" destId="{D118ED89-FD9D-4CA3-A887-18978A1C0FA4}" srcOrd="2" destOrd="0" presId="urn:microsoft.com/office/officeart/2005/8/layout/cycle8"/>
@@ -4282,13 +4237,6 @@
         </dgm:presLayoutVars>
       </dgm:prSet>
       <dgm:spPr/>
-      <dgm:t>
-        <a:bodyPr/>
-        <a:lstStyle/>
-        <a:p>
-          <a:endParaRPr lang="en-US"/>
-        </a:p>
-      </dgm:t>
     </dgm:pt>
     <dgm:pt modelId="{A643CC47-ACD4-4A18-B26E-98AC81F0672F}" type="pres">
       <dgm:prSet presAssocID="{8BB77BCF-7D51-4611-A490-30028F7A38C8}" presName="space" presStyleCnt="0"/>
@@ -4301,13 +4249,6 @@
         </dgm:presLayoutVars>
       </dgm:prSet>
       <dgm:spPr/>
-      <dgm:t>
-        <a:bodyPr/>
-        <a:lstStyle/>
-        <a:p>
-          <a:endParaRPr lang="en-US"/>
-        </a:p>
-      </dgm:t>
     </dgm:pt>
     <dgm:pt modelId="{C251A425-494D-42AF-8245-6C6654DD24FB}" type="pres">
       <dgm:prSet presAssocID="{9D249FD3-E762-43C5-9207-E9FCD229207A}" presName="space" presStyleCnt="0"/>
@@ -4320,23 +4261,16 @@
         </dgm:presLayoutVars>
       </dgm:prSet>
       <dgm:spPr/>
-      <dgm:t>
-        <a:bodyPr/>
-        <a:lstStyle/>
-        <a:p>
-          <a:endParaRPr lang="en-US"/>
-        </a:p>
-      </dgm:t>
     </dgm:pt>
   </dgm:ptLst>
   <dgm:cxnLst>
+    <dgm:cxn modelId="{A61C3909-F42F-4C69-999A-428F819708CE}" srcId="{39E8D5D3-EAA0-41A0-B6C6-1A67F84598BD}" destId="{A5A15C70-D3B9-4EC8-9AC8-4C41F2F6FFCC}" srcOrd="1" destOrd="0" parTransId="{0EF758B6-EE84-44CC-84BB-29C4D4FDC74B}" sibTransId="{9D249FD3-E762-43C5-9207-E9FCD229207A}"/>
     <dgm:cxn modelId="{F2E3DD0F-6547-4F10-8118-8CED2A95BF80}" srcId="{39E8D5D3-EAA0-41A0-B6C6-1A67F84598BD}" destId="{868F3690-A88C-4A66-9784-461667A8F764}" srcOrd="0" destOrd="0" parTransId="{2F2F7D05-97AA-4ECE-9385-3829F94B0CA8}" sibTransId="{8BB77BCF-7D51-4611-A490-30028F7A38C8}"/>
-    <dgm:cxn modelId="{42B848B8-EF78-4471-8EDF-8F06EC845E63}" type="presOf" srcId="{F9018FC5-9822-4F04-9097-9C8D563C8ABA}" destId="{D15B47C4-BF85-4374-80F2-7078EEF1CB47}" srcOrd="0" destOrd="0" presId="urn:diagrams.loki3.com/VaryingWidthList"/>
-    <dgm:cxn modelId="{A61C3909-F42F-4C69-999A-428F819708CE}" srcId="{39E8D5D3-EAA0-41A0-B6C6-1A67F84598BD}" destId="{A5A15C70-D3B9-4EC8-9AC8-4C41F2F6FFCC}" srcOrd="1" destOrd="0" parTransId="{0EF758B6-EE84-44CC-84BB-29C4D4FDC74B}" sibTransId="{9D249FD3-E762-43C5-9207-E9FCD229207A}"/>
     <dgm:cxn modelId="{46E11F46-7AE9-4D35-8D79-554C464C8CCF}" type="presOf" srcId="{39E8D5D3-EAA0-41A0-B6C6-1A67F84598BD}" destId="{77E58990-05A3-4695-B6CA-A709E1F97D9E}" srcOrd="0" destOrd="0" presId="urn:diagrams.loki3.com/VaryingWidthList"/>
     <dgm:cxn modelId="{ECC2E078-28C5-49AF-A4CA-D2141E989DC8}" type="presOf" srcId="{A5A15C70-D3B9-4EC8-9AC8-4C41F2F6FFCC}" destId="{F5105645-9B8E-4F3E-8708-F127B9FFABD4}" srcOrd="0" destOrd="0" presId="urn:diagrams.loki3.com/VaryingWidthList"/>
     <dgm:cxn modelId="{D8F11C88-DE97-4530-B186-8EE135C10872}" type="presOf" srcId="{868F3690-A88C-4A66-9784-461667A8F764}" destId="{58E51B73-C2E7-4B93-8CFD-A3490C56ED4C}" srcOrd="0" destOrd="0" presId="urn:diagrams.loki3.com/VaryingWidthList"/>
     <dgm:cxn modelId="{9F3B20A9-0074-4EF7-893C-FC67BF75FBBD}" srcId="{39E8D5D3-EAA0-41A0-B6C6-1A67F84598BD}" destId="{F9018FC5-9822-4F04-9097-9C8D563C8ABA}" srcOrd="2" destOrd="0" parTransId="{7B8A86C1-8783-496D-9020-8714AA807AAD}" sibTransId="{E738064A-2C30-4792-A9EE-F861575ECC8B}"/>
+    <dgm:cxn modelId="{42B848B8-EF78-4471-8EDF-8F06EC845E63}" type="presOf" srcId="{F9018FC5-9822-4F04-9097-9C8D563C8ABA}" destId="{D15B47C4-BF85-4374-80F2-7078EEF1CB47}" srcOrd="0" destOrd="0" presId="urn:diagrams.loki3.com/VaryingWidthList"/>
     <dgm:cxn modelId="{11F5D571-EE9D-4019-B435-2303D24CF9C6}" type="presParOf" srcId="{77E58990-05A3-4695-B6CA-A709E1F97D9E}" destId="{58E51B73-C2E7-4B93-8CFD-A3490C56ED4C}" srcOrd="0" destOrd="0" presId="urn:diagrams.loki3.com/VaryingWidthList"/>
     <dgm:cxn modelId="{ABCFF067-B7C6-4A5A-87DF-33F81D3721AB}" type="presParOf" srcId="{77E58990-05A3-4695-B6CA-A709E1F97D9E}" destId="{A643CC47-ACD4-4A18-B26E-98AC81F0672F}" srcOrd="1" destOrd="0" presId="urn:diagrams.loki3.com/VaryingWidthList"/>
     <dgm:cxn modelId="{19EACECE-5D38-49C8-881A-D313DAC95C36}" type="presParOf" srcId="{77E58990-05A3-4695-B6CA-A709E1F97D9E}" destId="{F5105645-9B8E-4F3E-8708-F127B9FFABD4}" srcOrd="2" destOrd="0" presId="urn:diagrams.loki3.com/VaryingWidthList"/>
@@ -4485,13 +4419,6 @@
         </dgm:presLayoutVars>
       </dgm:prSet>
       <dgm:spPr/>
-      <dgm:t>
-        <a:bodyPr/>
-        <a:lstStyle/>
-        <a:p>
-          <a:endParaRPr lang="en-US"/>
-        </a:p>
-      </dgm:t>
     </dgm:pt>
     <dgm:pt modelId="{46234A99-9D4E-4577-8ACC-86D55B0BC667}" type="pres">
       <dgm:prSet presAssocID="{5374AAC7-D7BC-42C4-8636-038CD9A4BC1C}" presName="Accent3" presStyleCnt="0"/>
@@ -4508,13 +4435,6 @@
     <dgm:pt modelId="{4730994F-E2D3-4E19-A76B-EB2096D54BB4}" type="pres">
       <dgm:prSet presAssocID="{5374AAC7-D7BC-42C4-8636-038CD9A4BC1C}" presName="ParentBackground" presStyleLbl="fgAcc1" presStyleIdx="0" presStyleCnt="3"/>
       <dgm:spPr/>
-      <dgm:t>
-        <a:bodyPr/>
-        <a:lstStyle/>
-        <a:p>
-          <a:endParaRPr lang="en-US"/>
-        </a:p>
-      </dgm:t>
     </dgm:pt>
     <dgm:pt modelId="{ADA68E60-36CB-4F93-B7D1-D6415B63A74B}" type="pres">
       <dgm:prSet presAssocID="{5374AAC7-D7BC-42C4-8636-038CD9A4BC1C}" presName="Parent3" presStyleLbl="revTx" presStyleIdx="0" presStyleCnt="0">
@@ -4525,13 +4445,6 @@
         </dgm:presLayoutVars>
       </dgm:prSet>
       <dgm:spPr/>
-      <dgm:t>
-        <a:bodyPr/>
-        <a:lstStyle/>
-        <a:p>
-          <a:endParaRPr lang="en-US"/>
-        </a:p>
-      </dgm:t>
     </dgm:pt>
     <dgm:pt modelId="{300329AB-7AAF-4C74-A148-67A32186E27A}" type="pres">
       <dgm:prSet presAssocID="{F5396E36-DF58-4EAF-9922-DB1771262B30}" presName="Accent2" presStyleCnt="0"/>
@@ -4548,13 +4461,6 @@
     <dgm:pt modelId="{27FFDD23-37EC-4981-9D16-3ADAE817054E}" type="pres">
       <dgm:prSet presAssocID="{F5396E36-DF58-4EAF-9922-DB1771262B30}" presName="ParentBackground" presStyleLbl="fgAcc1" presStyleIdx="1" presStyleCnt="3"/>
       <dgm:spPr/>
-      <dgm:t>
-        <a:bodyPr/>
-        <a:lstStyle/>
-        <a:p>
-          <a:endParaRPr lang="en-US"/>
-        </a:p>
-      </dgm:t>
     </dgm:pt>
     <dgm:pt modelId="{50BE5AA2-47D6-43EB-BEA6-50B094D7ECCC}" type="pres">
       <dgm:prSet presAssocID="{F5396E36-DF58-4EAF-9922-DB1771262B30}" presName="Parent2" presStyleLbl="revTx" presStyleIdx="0" presStyleCnt="0">
@@ -4565,13 +4471,6 @@
         </dgm:presLayoutVars>
       </dgm:prSet>
       <dgm:spPr/>
-      <dgm:t>
-        <a:bodyPr/>
-        <a:lstStyle/>
-        <a:p>
-          <a:endParaRPr lang="en-US"/>
-        </a:p>
-      </dgm:t>
     </dgm:pt>
     <dgm:pt modelId="{67F831D5-71C9-4D21-A957-61BB031C0499}" type="pres">
       <dgm:prSet presAssocID="{5DFD2E15-1B88-4955-8714-660854C64E3D}" presName="Accent1" presStyleCnt="0"/>
@@ -4588,13 +4487,6 @@
     <dgm:pt modelId="{759A9E96-EB7F-4199-A473-FF9327A56683}" type="pres">
       <dgm:prSet presAssocID="{5DFD2E15-1B88-4955-8714-660854C64E3D}" presName="ParentBackground" presStyleLbl="fgAcc1" presStyleIdx="2" presStyleCnt="3"/>
       <dgm:spPr/>
-      <dgm:t>
-        <a:bodyPr/>
-        <a:lstStyle/>
-        <a:p>
-          <a:endParaRPr lang="en-US"/>
-        </a:p>
-      </dgm:t>
     </dgm:pt>
     <dgm:pt modelId="{8DED8687-B28F-4ADA-810B-3A06EF198D6F}" type="pres">
       <dgm:prSet presAssocID="{5DFD2E15-1B88-4955-8714-660854C64E3D}" presName="Parent1" presStyleLbl="revTx" presStyleIdx="0" presStyleCnt="0">
@@ -4605,26 +4497,19 @@
         </dgm:presLayoutVars>
       </dgm:prSet>
       <dgm:spPr/>
-      <dgm:t>
-        <a:bodyPr/>
-        <a:lstStyle/>
-        <a:p>
-          <a:endParaRPr lang="en-US"/>
-        </a:p>
-      </dgm:t>
     </dgm:pt>
   </dgm:ptLst>
   <dgm:cxnLst>
+    <dgm:cxn modelId="{69C45169-6C13-405D-82C7-68B9A87F1B3C}" type="presOf" srcId="{1BB70AF1-5227-4E2B-87F4-01CFB23A19F3}" destId="{4E265830-AF10-4A24-81C3-67306D8756A6}" srcOrd="0" destOrd="0" presId="urn:microsoft.com/office/officeart/2011/layout/CircleProcess"/>
+    <dgm:cxn modelId="{EF02BD55-7D6B-4DF3-970D-5D5E1A59091E}" type="presOf" srcId="{F5396E36-DF58-4EAF-9922-DB1771262B30}" destId="{50BE5AA2-47D6-43EB-BEA6-50B094D7ECCC}" srcOrd="1" destOrd="0" presId="urn:microsoft.com/office/officeart/2011/layout/CircleProcess"/>
+    <dgm:cxn modelId="{44A2F08E-D989-4C97-ABF9-64BDAEB29F44}" type="presOf" srcId="{5DFD2E15-1B88-4955-8714-660854C64E3D}" destId="{759A9E96-EB7F-4199-A473-FF9327A56683}" srcOrd="0" destOrd="0" presId="urn:microsoft.com/office/officeart/2011/layout/CircleProcess"/>
+    <dgm:cxn modelId="{7C7E69A1-8212-4CEC-9B24-B7CBB09FC80E}" srcId="{1BB70AF1-5227-4E2B-87F4-01CFB23A19F3}" destId="{5374AAC7-D7BC-42C4-8636-038CD9A4BC1C}" srcOrd="2" destOrd="0" parTransId="{E4634909-9E6D-4261-8941-ED1EAAB8B50F}" sibTransId="{F115AFF0-88F1-4A15-AA9F-DB7257F53B3D}"/>
+    <dgm:cxn modelId="{5C6205A4-62FB-426D-A341-3B797E7C78CD}" type="presOf" srcId="{F5396E36-DF58-4EAF-9922-DB1771262B30}" destId="{27FFDD23-37EC-4981-9D16-3ADAE817054E}" srcOrd="0" destOrd="0" presId="urn:microsoft.com/office/officeart/2011/layout/CircleProcess"/>
+    <dgm:cxn modelId="{3CB455C1-38DF-49A4-9DB2-4F495D36D60F}" type="presOf" srcId="{5DFD2E15-1B88-4955-8714-660854C64E3D}" destId="{8DED8687-B28F-4ADA-810B-3A06EF198D6F}" srcOrd="1" destOrd="0" presId="urn:microsoft.com/office/officeart/2011/layout/CircleProcess"/>
     <dgm:cxn modelId="{B4B3E6C8-DDC6-41D5-8025-392A916D10DC}" srcId="{1BB70AF1-5227-4E2B-87F4-01CFB23A19F3}" destId="{5DFD2E15-1B88-4955-8714-660854C64E3D}" srcOrd="0" destOrd="0" parTransId="{4A235861-27A8-4417-9CF0-DE92DDA535A0}" sibTransId="{957553B1-6D66-4D15-A946-8B285F42E1EB}"/>
-    <dgm:cxn modelId="{3CB455C1-38DF-49A4-9DB2-4F495D36D60F}" type="presOf" srcId="{5DFD2E15-1B88-4955-8714-660854C64E3D}" destId="{8DED8687-B28F-4ADA-810B-3A06EF198D6F}" srcOrd="1" destOrd="0" presId="urn:microsoft.com/office/officeart/2011/layout/CircleProcess"/>
     <dgm:cxn modelId="{F9B4B5E2-0D54-41C3-8E15-20F361B78448}" srcId="{1BB70AF1-5227-4E2B-87F4-01CFB23A19F3}" destId="{F5396E36-DF58-4EAF-9922-DB1771262B30}" srcOrd="1" destOrd="0" parTransId="{2B29D7F6-A81F-47D6-B487-05B0E08790AE}" sibTransId="{325A1D28-DF43-475E-BFD4-790E2A64654A}"/>
-    <dgm:cxn modelId="{69C45169-6C13-405D-82C7-68B9A87F1B3C}" type="presOf" srcId="{1BB70AF1-5227-4E2B-87F4-01CFB23A19F3}" destId="{4E265830-AF10-4A24-81C3-67306D8756A6}" srcOrd="0" destOrd="0" presId="urn:microsoft.com/office/officeart/2011/layout/CircleProcess"/>
-    <dgm:cxn modelId="{7C7E69A1-8212-4CEC-9B24-B7CBB09FC80E}" srcId="{1BB70AF1-5227-4E2B-87F4-01CFB23A19F3}" destId="{5374AAC7-D7BC-42C4-8636-038CD9A4BC1C}" srcOrd="2" destOrd="0" parTransId="{E4634909-9E6D-4261-8941-ED1EAAB8B50F}" sibTransId="{F115AFF0-88F1-4A15-AA9F-DB7257F53B3D}"/>
     <dgm:cxn modelId="{F897D2E7-885C-4B06-866E-79738458CFA1}" type="presOf" srcId="{5374AAC7-D7BC-42C4-8636-038CD9A4BC1C}" destId="{4730994F-E2D3-4E19-A76B-EB2096D54BB4}" srcOrd="0" destOrd="0" presId="urn:microsoft.com/office/officeart/2011/layout/CircleProcess"/>
-    <dgm:cxn modelId="{44A2F08E-D989-4C97-ABF9-64BDAEB29F44}" type="presOf" srcId="{5DFD2E15-1B88-4955-8714-660854C64E3D}" destId="{759A9E96-EB7F-4199-A473-FF9327A56683}" srcOrd="0" destOrd="0" presId="urn:microsoft.com/office/officeart/2011/layout/CircleProcess"/>
-    <dgm:cxn modelId="{5C6205A4-62FB-426D-A341-3B797E7C78CD}" type="presOf" srcId="{F5396E36-DF58-4EAF-9922-DB1771262B30}" destId="{27FFDD23-37EC-4981-9D16-3ADAE817054E}" srcOrd="0" destOrd="0" presId="urn:microsoft.com/office/officeart/2011/layout/CircleProcess"/>
     <dgm:cxn modelId="{915DF8F6-96BB-48BA-B225-2C29B82A4A9E}" type="presOf" srcId="{5374AAC7-D7BC-42C4-8636-038CD9A4BC1C}" destId="{ADA68E60-36CB-4F93-B7D1-D6415B63A74B}" srcOrd="1" destOrd="0" presId="urn:microsoft.com/office/officeart/2011/layout/CircleProcess"/>
-    <dgm:cxn modelId="{EF02BD55-7D6B-4DF3-970D-5D5E1A59091E}" type="presOf" srcId="{F5396E36-DF58-4EAF-9922-DB1771262B30}" destId="{50BE5AA2-47D6-43EB-BEA6-50B094D7ECCC}" srcOrd="1" destOrd="0" presId="urn:microsoft.com/office/officeart/2011/layout/CircleProcess"/>
     <dgm:cxn modelId="{7DBBB739-C96B-4090-8CBC-AE703ADB8DF5}" type="presParOf" srcId="{4E265830-AF10-4A24-81C3-67306D8756A6}" destId="{46234A99-9D4E-4577-8ACC-86D55B0BC667}" srcOrd="0" destOrd="0" presId="urn:microsoft.com/office/officeart/2011/layout/CircleProcess"/>
     <dgm:cxn modelId="{734E01F9-6331-4D78-B8BA-E22528F48F2C}" type="presParOf" srcId="{46234A99-9D4E-4577-8ACC-86D55B0BC667}" destId="{FCC23218-8029-4542-BBD7-F0D763281859}" srcOrd="0" destOrd="0" presId="urn:microsoft.com/office/officeart/2011/layout/CircleProcess"/>
     <dgm:cxn modelId="{CE874A3C-2546-44C1-AB5C-572B32B0EEDF}" type="presParOf" srcId="{4E265830-AF10-4A24-81C3-67306D8756A6}" destId="{2615E59C-1026-4787-A5C2-553D1B83F81B}" srcOrd="1" destOrd="0" presId="urn:microsoft.com/office/officeart/2011/layout/CircleProcess"/>
@@ -4746,13 +4631,6 @@
         </dgm:presLayoutVars>
       </dgm:prSet>
       <dgm:spPr/>
-      <dgm:t>
-        <a:bodyPr/>
-        <a:lstStyle/>
-        <a:p>
-          <a:endParaRPr lang="en-US"/>
-        </a:p>
-      </dgm:t>
     </dgm:pt>
     <dgm:pt modelId="{79CF224D-4EC5-4777-A7AE-01CF18E0F804}" type="pres">
       <dgm:prSet presAssocID="{62BAAA0D-9349-4CB7-B615-D606801F76A9}" presName="divider" presStyleLbl="fgShp" presStyleIdx="0" presStyleCnt="1"/>
@@ -4769,13 +4647,6 @@
         </dgm:presLayoutVars>
       </dgm:prSet>
       <dgm:spPr/>
-      <dgm:t>
-        <a:bodyPr/>
-        <a:lstStyle/>
-        <a:p>
-          <a:endParaRPr lang="en-US"/>
-        </a:p>
-      </dgm:t>
     </dgm:pt>
     <dgm:pt modelId="{924BF623-4B96-41F8-92FC-FEC5C46D723E}" type="pres">
       <dgm:prSet presAssocID="{FA506319-5FAC-44C3-B46A-6E7C99782C7D}" presName="upArrow" presStyleLbl="node1" presStyleIdx="1" presStyleCnt="2"/>
@@ -4788,21 +4659,14 @@
         </dgm:presLayoutVars>
       </dgm:prSet>
       <dgm:spPr/>
-      <dgm:t>
-        <a:bodyPr/>
-        <a:lstStyle/>
-        <a:p>
-          <a:endParaRPr lang="en-US"/>
-        </a:p>
-      </dgm:t>
     </dgm:pt>
   </dgm:ptLst>
   <dgm:cxnLst>
-    <dgm:cxn modelId="{BF7B42D1-642E-4A63-97FB-F6C008A07DA0}" srcId="{62BAAA0D-9349-4CB7-B615-D606801F76A9}" destId="{C2BEAFD3-B7EF-47FC-83CA-7812938FB2ED}" srcOrd="0" destOrd="0" parTransId="{DD237862-57EF-492C-B889-AD58C7CA0346}" sibTransId="{E1239AB3-A325-4F1C-8974-E9835F105845}"/>
     <dgm:cxn modelId="{30764D35-6E5F-4F0F-BD18-EBC78D91AB9A}" type="presOf" srcId="{C2BEAFD3-B7EF-47FC-83CA-7812938FB2ED}" destId="{AE427642-BB0E-4604-971F-7471A74FF2BB}" srcOrd="0" destOrd="0" presId="urn:microsoft.com/office/officeart/2005/8/layout/arrow3"/>
     <dgm:cxn modelId="{6B25EA75-57C1-4D90-98D8-9C3DD0B49ADA}" type="presOf" srcId="{FA506319-5FAC-44C3-B46A-6E7C99782C7D}" destId="{C9FA7441-B263-4A2D-808E-C971354A5353}" srcOrd="0" destOrd="0" presId="urn:microsoft.com/office/officeart/2005/8/layout/arrow3"/>
+    <dgm:cxn modelId="{52CFBA83-16B4-4986-A856-9CA50A498ED6}" srcId="{62BAAA0D-9349-4CB7-B615-D606801F76A9}" destId="{FA506319-5FAC-44C3-B46A-6E7C99782C7D}" srcOrd="1" destOrd="0" parTransId="{B153AAE1-58A1-44E6-8392-E18524683C4B}" sibTransId="{BBB512BB-EBA7-4C4E-97A7-E769B9043CED}"/>
     <dgm:cxn modelId="{C23EBAA1-B16F-4E2B-8012-782A001E2294}" type="presOf" srcId="{62BAAA0D-9349-4CB7-B615-D606801F76A9}" destId="{5660CE79-418B-4B8F-9C7D-5306C42BDE89}" srcOrd="0" destOrd="0" presId="urn:microsoft.com/office/officeart/2005/8/layout/arrow3"/>
-    <dgm:cxn modelId="{52CFBA83-16B4-4986-A856-9CA50A498ED6}" srcId="{62BAAA0D-9349-4CB7-B615-D606801F76A9}" destId="{FA506319-5FAC-44C3-B46A-6E7C99782C7D}" srcOrd="1" destOrd="0" parTransId="{B153AAE1-58A1-44E6-8392-E18524683C4B}" sibTransId="{BBB512BB-EBA7-4C4E-97A7-E769B9043CED}"/>
+    <dgm:cxn modelId="{BF7B42D1-642E-4A63-97FB-F6C008A07DA0}" srcId="{62BAAA0D-9349-4CB7-B615-D606801F76A9}" destId="{C2BEAFD3-B7EF-47FC-83CA-7812938FB2ED}" srcOrd="0" destOrd="0" parTransId="{DD237862-57EF-492C-B889-AD58C7CA0346}" sibTransId="{E1239AB3-A325-4F1C-8974-E9835F105845}"/>
     <dgm:cxn modelId="{2E812EC0-3FFE-4354-A7A8-D3139091ADE0}" type="presParOf" srcId="{5660CE79-418B-4B8F-9C7D-5306C42BDE89}" destId="{79CF224D-4EC5-4777-A7AE-01CF18E0F804}" srcOrd="0" destOrd="0" presId="urn:microsoft.com/office/officeart/2005/8/layout/arrow3"/>
     <dgm:cxn modelId="{774DBC94-DF6A-4D20-B6F9-12E76150D7C1}" type="presParOf" srcId="{5660CE79-418B-4B8F-9C7D-5306C42BDE89}" destId="{9E3FAB49-F448-4E0B-81C6-97AFABC920B5}" srcOrd="1" destOrd="0" presId="urn:microsoft.com/office/officeart/2005/8/layout/arrow3"/>
     <dgm:cxn modelId="{40E5E8E5-5FC7-409D-B83A-E26A00CF3E21}" type="presParOf" srcId="{5660CE79-418B-4B8F-9C7D-5306C42BDE89}" destId="{AE427642-BB0E-4604-971F-7471A74FF2BB}" srcOrd="2" destOrd="0" presId="urn:microsoft.com/office/officeart/2005/8/layout/arrow3"/>
@@ -5058,13 +4922,6 @@
         </dgm:presLayoutVars>
       </dgm:prSet>
       <dgm:spPr/>
-      <dgm:t>
-        <a:bodyPr/>
-        <a:lstStyle/>
-        <a:p>
-          <a:endParaRPr lang="en-US"/>
-        </a:p>
-      </dgm:t>
     </dgm:pt>
     <dgm:pt modelId="{D539BAF3-E038-4627-BFAD-B9D392E703CA}" type="pres">
       <dgm:prSet presAssocID="{6EDBE84E-0D22-499B-B42F-9B854419D13D}" presName="linNode" presStyleCnt="0"/>
@@ -5077,13 +4934,6 @@
         </dgm:presLayoutVars>
       </dgm:prSet>
       <dgm:spPr/>
-      <dgm:t>
-        <a:bodyPr/>
-        <a:lstStyle/>
-        <a:p>
-          <a:endParaRPr lang="en-US"/>
-        </a:p>
-      </dgm:t>
     </dgm:pt>
     <dgm:pt modelId="{E3759595-354F-400B-95DD-89A782A8B4B2}" type="pres">
       <dgm:prSet presAssocID="{6EDBE84E-0D22-499B-B42F-9B854419D13D}" presName="childShp" presStyleLbl="bgAccFollowNode1" presStyleIdx="0" presStyleCnt="2">
@@ -5092,13 +4942,6 @@
         </dgm:presLayoutVars>
       </dgm:prSet>
       <dgm:spPr/>
-      <dgm:t>
-        <a:bodyPr/>
-        <a:lstStyle/>
-        <a:p>
-          <a:endParaRPr lang="en-US"/>
-        </a:p>
-      </dgm:t>
     </dgm:pt>
     <dgm:pt modelId="{FBEE5982-86C4-466B-8905-E95F62D203B2}" type="pres">
       <dgm:prSet presAssocID="{78BBB547-353D-4556-9ECD-BDE53DDC7AAB}" presName="spacing" presStyleCnt="0"/>
@@ -5115,13 +4958,6 @@
         </dgm:presLayoutVars>
       </dgm:prSet>
       <dgm:spPr/>
-      <dgm:t>
-        <a:bodyPr/>
-        <a:lstStyle/>
-        <a:p>
-          <a:endParaRPr lang="en-US"/>
-        </a:p>
-      </dgm:t>
     </dgm:pt>
     <dgm:pt modelId="{E5EF4B17-5002-40FF-B393-A5E7F7527EC0}" type="pres">
       <dgm:prSet presAssocID="{8DF8A578-D7F2-49F3-B34C-97B7DCC6E51E}" presName="childShp" presStyleLbl="bgAccFollowNode1" presStyleIdx="1" presStyleCnt="2">
@@ -5130,29 +4966,22 @@
         </dgm:presLayoutVars>
       </dgm:prSet>
       <dgm:spPr/>
-      <dgm:t>
-        <a:bodyPr/>
-        <a:lstStyle/>
-        <a:p>
-          <a:endParaRPr lang="en-US"/>
-        </a:p>
-      </dgm:t>
     </dgm:pt>
   </dgm:ptLst>
   <dgm:cxnLst>
-    <dgm:cxn modelId="{F4742AF6-3F13-40EB-9330-CB386DF95EAB}" type="presOf" srcId="{65230ADB-BE6D-4560-9902-FF6E08322562}" destId="{E3759595-354F-400B-95DD-89A782A8B4B2}" srcOrd="0" destOrd="1" presId="urn:microsoft.com/office/officeart/2005/8/layout/vList6"/>
+    <dgm:cxn modelId="{27CC0602-D6B4-400C-BA9A-78F1937F45B1}" srcId="{8DF8A578-D7F2-49F3-B34C-97B7DCC6E51E}" destId="{6A0B8FCF-3810-40AD-96A8-5C99BD66787F}" srcOrd="1" destOrd="0" parTransId="{1B763566-0F27-4C84-B80C-B4891A4B9DEF}" sibTransId="{F011D4D1-F32D-4241-AD48-6D4FDD829252}"/>
+    <dgm:cxn modelId="{22F11D22-F55C-4F26-A154-52BBA595ADD0}" srcId="{6EDBE84E-0D22-499B-B42F-9B854419D13D}" destId="{65230ADB-BE6D-4560-9902-FF6E08322562}" srcOrd="1" destOrd="0" parTransId="{6E3C649D-911A-45A6-BCF5-9DFA91FEFD27}" sibTransId="{957BBE1C-7CF6-4979-8EB8-EDCBD865C065}"/>
+    <dgm:cxn modelId="{34FD444E-3163-4E7F-BB15-D5C23EF7995E}" srcId="{8DF8A578-D7F2-49F3-B34C-97B7DCC6E51E}" destId="{A6270011-9A70-4F5A-AE86-E2CC4D594DBC}" srcOrd="0" destOrd="0" parTransId="{A5B314A7-D45F-41D4-A061-545EAEB6B239}" sibTransId="{B9B39BC4-F826-4CEE-ABEA-AF36BCBB0F10}"/>
+    <dgm:cxn modelId="{D3E7E04E-40EB-4F78-9E32-D9A3806D989B}" type="presOf" srcId="{A6270011-9A70-4F5A-AE86-E2CC4D594DBC}" destId="{E5EF4B17-5002-40FF-B393-A5E7F7527EC0}" srcOrd="0" destOrd="0" presId="urn:microsoft.com/office/officeart/2005/8/layout/vList6"/>
+    <dgm:cxn modelId="{066F1C70-E1AC-479A-B9CA-3F1E9E787802}" type="presOf" srcId="{658F3D1C-3BEA-43DC-AC7E-E560EEC57642}" destId="{E3759595-354F-400B-95DD-89A782A8B4B2}" srcOrd="0" destOrd="0" presId="urn:microsoft.com/office/officeart/2005/8/layout/vList6"/>
+    <dgm:cxn modelId="{15AA127A-5FED-4FE1-A7A7-FA8303B9CFF6}" type="presOf" srcId="{8DF8A578-D7F2-49F3-B34C-97B7DCC6E51E}" destId="{C119FDEB-0024-4314-8368-8689DB45D9ED}" srcOrd="0" destOrd="0" presId="urn:microsoft.com/office/officeart/2005/8/layout/vList6"/>
     <dgm:cxn modelId="{8C1C0E94-1254-4B5E-B445-105E91832C15}" type="presOf" srcId="{5A711DA4-97C8-4B25-A936-6001CA079E19}" destId="{9D8D3346-47DA-4240-B204-F8267C92E0BB}" srcOrd="0" destOrd="0" presId="urn:microsoft.com/office/officeart/2005/8/layout/vList6"/>
-    <dgm:cxn modelId="{591987D3-7CB2-4EE1-A52E-1963DA70102C}" srcId="{5A711DA4-97C8-4B25-A936-6001CA079E19}" destId="{8DF8A578-D7F2-49F3-B34C-97B7DCC6E51E}" srcOrd="1" destOrd="0" parTransId="{33B5B5EA-EB0E-446A-AFFD-8FAD918468F8}" sibTransId="{08258886-909B-44DF-A860-87922564EF7B}"/>
-    <dgm:cxn modelId="{27CC0602-D6B4-400C-BA9A-78F1937F45B1}" srcId="{8DF8A578-D7F2-49F3-B34C-97B7DCC6E51E}" destId="{6A0B8FCF-3810-40AD-96A8-5C99BD66787F}" srcOrd="1" destOrd="0" parTransId="{1B763566-0F27-4C84-B80C-B4891A4B9DEF}" sibTransId="{F011D4D1-F32D-4241-AD48-6D4FDD829252}"/>
-    <dgm:cxn modelId="{34FD444E-3163-4E7F-BB15-D5C23EF7995E}" srcId="{8DF8A578-D7F2-49F3-B34C-97B7DCC6E51E}" destId="{A6270011-9A70-4F5A-AE86-E2CC4D594DBC}" srcOrd="0" destOrd="0" parTransId="{A5B314A7-D45F-41D4-A061-545EAEB6B239}" sibTransId="{B9B39BC4-F826-4CEE-ABEA-AF36BCBB0F10}"/>
-    <dgm:cxn modelId="{066F1C70-E1AC-479A-B9CA-3F1E9E787802}" type="presOf" srcId="{658F3D1C-3BEA-43DC-AC7E-E560EEC57642}" destId="{E3759595-354F-400B-95DD-89A782A8B4B2}" srcOrd="0" destOrd="0" presId="urn:microsoft.com/office/officeart/2005/8/layout/vList6"/>
-    <dgm:cxn modelId="{22F11D22-F55C-4F26-A154-52BBA595ADD0}" srcId="{6EDBE84E-0D22-499B-B42F-9B854419D13D}" destId="{65230ADB-BE6D-4560-9902-FF6E08322562}" srcOrd="1" destOrd="0" parTransId="{6E3C649D-911A-45A6-BCF5-9DFA91FEFD27}" sibTransId="{957BBE1C-7CF6-4979-8EB8-EDCBD865C065}"/>
-    <dgm:cxn modelId="{D3E7E04E-40EB-4F78-9E32-D9A3806D989B}" type="presOf" srcId="{A6270011-9A70-4F5A-AE86-E2CC4D594DBC}" destId="{E5EF4B17-5002-40FF-B393-A5E7F7527EC0}" srcOrd="0" destOrd="0" presId="urn:microsoft.com/office/officeart/2005/8/layout/vList6"/>
     <dgm:cxn modelId="{279D52B9-EC14-4980-9AA6-99B301B809F2}" type="presOf" srcId="{6EDBE84E-0D22-499B-B42F-9B854419D13D}" destId="{0C0A45FE-EE8D-440C-BCB0-7EEF5B511C15}" srcOrd="0" destOrd="0" presId="urn:microsoft.com/office/officeart/2005/8/layout/vList6"/>
     <dgm:cxn modelId="{CA39F8C9-9F43-4F85-9ED7-99C40937C5CA}" srcId="{5A711DA4-97C8-4B25-A936-6001CA079E19}" destId="{6EDBE84E-0D22-499B-B42F-9B854419D13D}" srcOrd="0" destOrd="0" parTransId="{4CF26A79-624A-4EBB-9570-F1C122AC595E}" sibTransId="{78BBB547-353D-4556-9ECD-BDE53DDC7AAB}"/>
+    <dgm:cxn modelId="{3A65B5CE-34E8-4DF6-BE43-F65990ED9544}" type="presOf" srcId="{6A0B8FCF-3810-40AD-96A8-5C99BD66787F}" destId="{E5EF4B17-5002-40FF-B393-A5E7F7527EC0}" srcOrd="0" destOrd="1" presId="urn:microsoft.com/office/officeart/2005/8/layout/vList6"/>
+    <dgm:cxn modelId="{591987D3-7CB2-4EE1-A52E-1963DA70102C}" srcId="{5A711DA4-97C8-4B25-A936-6001CA079E19}" destId="{8DF8A578-D7F2-49F3-B34C-97B7DCC6E51E}" srcOrd="1" destOrd="0" parTransId="{33B5B5EA-EB0E-446A-AFFD-8FAD918468F8}" sibTransId="{08258886-909B-44DF-A860-87922564EF7B}"/>
     <dgm:cxn modelId="{A41794DE-2B3E-4785-8806-EA3AE758039B}" srcId="{6EDBE84E-0D22-499B-B42F-9B854419D13D}" destId="{658F3D1C-3BEA-43DC-AC7E-E560EEC57642}" srcOrd="0" destOrd="0" parTransId="{464EEC0C-A33E-4CA8-B9AA-A397727A6C2A}" sibTransId="{4EC79217-355A-44B0-9621-603BDAE06AF6}"/>
-    <dgm:cxn modelId="{15AA127A-5FED-4FE1-A7A7-FA8303B9CFF6}" type="presOf" srcId="{8DF8A578-D7F2-49F3-B34C-97B7DCC6E51E}" destId="{C119FDEB-0024-4314-8368-8689DB45D9ED}" srcOrd="0" destOrd="0" presId="urn:microsoft.com/office/officeart/2005/8/layout/vList6"/>
-    <dgm:cxn modelId="{3A65B5CE-34E8-4DF6-BE43-F65990ED9544}" type="presOf" srcId="{6A0B8FCF-3810-40AD-96A8-5C99BD66787F}" destId="{E5EF4B17-5002-40FF-B393-A5E7F7527EC0}" srcOrd="0" destOrd="1" presId="urn:microsoft.com/office/officeart/2005/8/layout/vList6"/>
+    <dgm:cxn modelId="{F4742AF6-3F13-40EB-9330-CB386DF95EAB}" type="presOf" srcId="{65230ADB-BE6D-4560-9902-FF6E08322562}" destId="{E3759595-354F-400B-95DD-89A782A8B4B2}" srcOrd="0" destOrd="1" presId="urn:microsoft.com/office/officeart/2005/8/layout/vList6"/>
     <dgm:cxn modelId="{7D9D2A05-3BB2-4D60-A41D-81A08FA9BE2D}" type="presParOf" srcId="{9D8D3346-47DA-4240-B204-F8267C92E0BB}" destId="{D539BAF3-E038-4627-BFAD-B9D392E703CA}" srcOrd="0" destOrd="0" presId="urn:microsoft.com/office/officeart/2005/8/layout/vList6"/>
     <dgm:cxn modelId="{D94774B1-5CCD-4A53-A6F2-3B479B0FB3DB}" type="presParOf" srcId="{D539BAF3-E038-4627-BFAD-B9D392E703CA}" destId="{0C0A45FE-EE8D-440C-BCB0-7EEF5B511C15}" srcOrd="0" destOrd="0" presId="urn:microsoft.com/office/officeart/2005/8/layout/vList6"/>
     <dgm:cxn modelId="{BD00D194-AD9D-43F3-A978-4BAC3FEB5588}" type="presParOf" srcId="{D539BAF3-E038-4627-BFAD-B9D392E703CA}" destId="{E3759595-354F-400B-95DD-89A782A8B4B2}" srcOrd="1" destOrd="0" presId="urn:microsoft.com/office/officeart/2005/8/layout/vList6"/>
@@ -5237,7 +5066,7 @@
         </a:bodyPr>
         <a:lstStyle/>
         <a:p>
-          <a:pPr lvl="0" algn="ctr" defTabSz="1511300">
+          <a:pPr marL="0" lvl="0" indent="0" algn="ctr" defTabSz="1511300">
             <a:lnSpc>
               <a:spcPct val="90000"/>
             </a:lnSpc>
@@ -5247,6 +5076,7 @@
             <a:spcAft>
               <a:spcPct val="35000"/>
             </a:spcAft>
+            <a:buNone/>
           </a:pPr>
           <a:r>
             <a:rPr lang="en-US" sz="3400" kern="1200" dirty="0"/>
@@ -5317,7 +5147,7 @@
         </a:bodyPr>
         <a:lstStyle/>
         <a:p>
-          <a:pPr lvl="0" algn="ctr" defTabSz="1511300">
+          <a:pPr marL="0" lvl="0" indent="0" algn="ctr" defTabSz="1511300">
             <a:lnSpc>
               <a:spcPct val="90000"/>
             </a:lnSpc>
@@ -5327,6 +5157,7 @@
             <a:spcAft>
               <a:spcPct val="35000"/>
             </a:spcAft>
+            <a:buNone/>
           </a:pPr>
           <a:r>
             <a:rPr lang="en-US" sz="3400" kern="1200" dirty="0"/>
@@ -5397,7 +5228,7 @@
         </a:bodyPr>
         <a:lstStyle/>
         <a:p>
-          <a:pPr lvl="0" algn="ctr" defTabSz="1511300">
+          <a:pPr marL="0" lvl="0" indent="0" algn="ctr" defTabSz="1511300">
             <a:lnSpc>
               <a:spcPct val="90000"/>
             </a:lnSpc>
@@ -5407,6 +5238,7 @@
             <a:spcAft>
               <a:spcPct val="35000"/>
             </a:spcAft>
+            <a:buNone/>
           </a:pPr>
           <a:r>
             <a:rPr lang="en-US" sz="3400" kern="1200" dirty="0"/>
@@ -5651,7 +5483,7 @@
         </a:bodyPr>
         <a:lstStyle/>
         <a:p>
-          <a:pPr lvl="0" algn="ctr" defTabSz="2889250">
+          <a:pPr marL="0" lvl="0" indent="0" algn="ctr" defTabSz="2889250">
             <a:lnSpc>
               <a:spcPct val="90000"/>
             </a:lnSpc>
@@ -5661,6 +5493,7 @@
             <a:spcAft>
               <a:spcPct val="35000"/>
             </a:spcAft>
+            <a:buNone/>
           </a:pPr>
           <a:r>
             <a:rPr lang="en-US" sz="6500" kern="1200" dirty="0"/>
@@ -5749,7 +5582,7 @@
         </a:bodyPr>
         <a:lstStyle/>
         <a:p>
-          <a:pPr lvl="0" algn="ctr" defTabSz="2889250">
+          <a:pPr marL="0" lvl="0" indent="0" algn="ctr" defTabSz="2889250">
             <a:lnSpc>
               <a:spcPct val="90000"/>
             </a:lnSpc>
@@ -5759,6 +5592,7 @@
             <a:spcAft>
               <a:spcPct val="35000"/>
             </a:spcAft>
+            <a:buNone/>
           </a:pPr>
           <a:r>
             <a:rPr lang="en-US" sz="6500" kern="1200" dirty="0"/>
@@ -5847,7 +5681,7 @@
         </a:bodyPr>
         <a:lstStyle/>
         <a:p>
-          <a:pPr lvl="0" algn="ctr" defTabSz="2889250">
+          <a:pPr marL="0" lvl="0" indent="0" algn="ctr" defTabSz="2889250">
             <a:lnSpc>
               <a:spcPct val="90000"/>
             </a:lnSpc>
@@ -5857,6 +5691,7 @@
             <a:spcAft>
               <a:spcPct val="35000"/>
             </a:spcAft>
+            <a:buNone/>
           </a:pPr>
           <a:r>
             <a:rPr lang="en-US" sz="6500" kern="1200" dirty="0"/>
@@ -6012,7 +5847,7 @@
         </a:bodyPr>
         <a:lstStyle/>
         <a:p>
-          <a:pPr lvl="0" algn="ctr" defTabSz="1289050">
+          <a:pPr marL="0" lvl="0" indent="0" algn="ctr" defTabSz="1289050">
             <a:lnSpc>
               <a:spcPct val="90000"/>
             </a:lnSpc>
@@ -6022,6 +5857,7 @@
             <a:spcAft>
               <a:spcPct val="35000"/>
             </a:spcAft>
+            <a:buNone/>
           </a:pPr>
           <a:r>
             <a:rPr lang="en-US" sz="2900" b="1" kern="1200" dirty="0"/>
@@ -6167,7 +6003,7 @@
         </a:bodyPr>
         <a:lstStyle/>
         <a:p>
-          <a:pPr lvl="0" algn="ctr" defTabSz="1289050">
+          <a:pPr marL="0" lvl="0" indent="0" algn="ctr" defTabSz="1289050">
             <a:lnSpc>
               <a:spcPct val="90000"/>
             </a:lnSpc>
@@ -6177,6 +6013,7 @@
             <a:spcAft>
               <a:spcPct val="35000"/>
             </a:spcAft>
+            <a:buNone/>
           </a:pPr>
           <a:r>
             <a:rPr lang="en-US" sz="2900" b="1" kern="1200" dirty="0"/>
@@ -6322,7 +6159,7 @@
         </a:bodyPr>
         <a:lstStyle/>
         <a:p>
-          <a:pPr lvl="0" algn="ctr" defTabSz="1289050">
+          <a:pPr marL="0" lvl="0" indent="0" algn="ctr" defTabSz="1289050">
             <a:lnSpc>
               <a:spcPct val="90000"/>
             </a:lnSpc>
@@ -6332,6 +6169,7 @@
             <a:spcAft>
               <a:spcPct val="35000"/>
             </a:spcAft>
+            <a:buNone/>
           </a:pPr>
           <a:r>
             <a:rPr lang="en-US" sz="2900" b="1" kern="1200" dirty="0"/>
@@ -6492,7 +6330,7 @@
         </a:bodyPr>
         <a:lstStyle/>
         <a:p>
-          <a:pPr lvl="0" algn="ctr" defTabSz="1866900">
+          <a:pPr marL="0" lvl="0" indent="0" algn="ctr" defTabSz="1866900">
             <a:lnSpc>
               <a:spcPct val="90000"/>
             </a:lnSpc>
@@ -6502,6 +6340,7 @@
             <a:spcAft>
               <a:spcPct val="35000"/>
             </a:spcAft>
+            <a:buNone/>
           </a:pPr>
           <a:r>
             <a:rPr lang="en-US" sz="4200" kern="1200" dirty="0"/>
@@ -6601,7 +6440,7 @@
         </a:bodyPr>
         <a:lstStyle/>
         <a:p>
-          <a:pPr lvl="0" algn="ctr" defTabSz="1866900">
+          <a:pPr marL="0" lvl="0" indent="0" algn="ctr" defTabSz="1866900">
             <a:lnSpc>
               <a:spcPct val="90000"/>
             </a:lnSpc>
@@ -6611,6 +6450,7 @@
             <a:spcAft>
               <a:spcPct val="35000"/>
             </a:spcAft>
+            <a:buNone/>
           </a:pPr>
           <a:r>
             <a:rPr lang="en-US" sz="4200" kern="1200" dirty="0"/>
@@ -6705,7 +6545,7 @@
             <a:spcAft>
               <a:spcPct val="15000"/>
             </a:spcAft>
-            <a:buChar char="••"/>
+            <a:buChar char="•"/>
           </a:pPr>
           <a:r>
             <a:rPr lang="en-US" sz="4100" kern="1200" dirty="0"/>
@@ -6723,7 +6563,7 @@
             <a:spcAft>
               <a:spcPct val="15000"/>
             </a:spcAft>
-            <a:buChar char="••"/>
+            <a:buChar char="•"/>
           </a:pPr>
           <a:r>
             <a:rPr lang="en-US" sz="4100" kern="1200" dirty="0"/>
@@ -6791,7 +6631,7 @@
         </a:bodyPr>
         <a:lstStyle/>
         <a:p>
-          <a:pPr lvl="0" algn="ctr" defTabSz="1733550">
+          <a:pPr marL="0" lvl="0" indent="0" algn="ctr" defTabSz="1733550">
             <a:lnSpc>
               <a:spcPct val="90000"/>
             </a:lnSpc>
@@ -6801,6 +6641,7 @@
             <a:spcAft>
               <a:spcPct val="35000"/>
             </a:spcAft>
+            <a:buNone/>
           </a:pPr>
           <a:r>
             <a:rPr lang="en-US" sz="3900" kern="1200" dirty="0"/>
@@ -6883,7 +6724,7 @@
             <a:spcAft>
               <a:spcPct val="15000"/>
             </a:spcAft>
-            <a:buChar char="••"/>
+            <a:buChar char="•"/>
           </a:pPr>
           <a:r>
             <a:rPr lang="en-US" sz="4100" kern="1200" dirty="0"/>
@@ -6901,7 +6742,7 @@
             <a:spcAft>
               <a:spcPct val="15000"/>
             </a:spcAft>
-            <a:buChar char="••"/>
+            <a:buChar char="•"/>
           </a:pPr>
           <a:r>
             <a:rPr lang="en-US" sz="4100" kern="1200" dirty="0"/>
@@ -6969,7 +6810,7 @@
         </a:bodyPr>
         <a:lstStyle/>
         <a:p>
-          <a:pPr lvl="0" algn="ctr" defTabSz="1733550">
+          <a:pPr marL="0" lvl="0" indent="0" algn="ctr" defTabSz="1733550">
             <a:lnSpc>
               <a:spcPct val="90000"/>
             </a:lnSpc>
@@ -6979,6 +6820,7 @@
             <a:spcAft>
               <a:spcPct val="35000"/>
             </a:spcAft>
+            <a:buNone/>
           </a:pPr>
           <a:r>
             <a:rPr lang="en-US" sz="3900" kern="1200" dirty="0"/>
@@ -18963,921 +18805,6 @@
 </file>
 
 <file path=ppt/slideLayouts/slideLayout1.xml><?xml version="1.0" encoding="utf-8"?>
-<p:sldLayout xmlns:a="http://schemas.openxmlformats.org/drawingml/2006/main" xmlns:r="http://schemas.openxmlformats.org/officeDocument/2006/relationships" xmlns:p="http://schemas.openxmlformats.org/presentationml/2006/main" userDrawn="1">
-  <p:cSld name="1_Title Slide">
-    <p:spTree>
-      <p:nvGrpSpPr>
-        <p:cNvPr id="1" name=""/>
-        <p:cNvGrpSpPr/>
-        <p:nvPr/>
-      </p:nvGrpSpPr>
-      <p:grpSpPr>
-        <a:xfrm>
-          <a:off x="0" y="0"/>
-          <a:ext cx="0" cy="0"/>
-          <a:chOff x="0" y="0"/>
-          <a:chExt cx="0" cy="0"/>
-        </a:xfrm>
-      </p:grpSpPr>
-      <p:pic>
-        <p:nvPicPr>
-          <p:cNvPr id="7" name="Picture 6"/>
-          <p:cNvPicPr>
-            <a:picLocks noChangeAspect="1"/>
-          </p:cNvPicPr>
-          <p:nvPr userDrawn="1"/>
-        </p:nvPicPr>
-        <p:blipFill rotWithShape="1">
-          <a:blip r:embed="rId2">
-            <a:grayscl/>
-            <a:extLst>
-              <a:ext uri="{28A0092B-C50C-407E-A947-70E740481C1C}">
-                <a14:useLocalDpi xmlns:a14="http://schemas.microsoft.com/office/drawing/2010/main" val="0"/>
-              </a:ext>
-            </a:extLst>
-          </a:blip>
-          <a:srcRect t="3186" b="1180"/>
-          <a:stretch/>
-        </p:blipFill>
-        <p:spPr>
-          <a:xfrm>
-            <a:off x="1" y="0"/>
-            <a:ext cx="12192000" cy="6858000"/>
-          </a:xfrm>
-          <a:prstGeom prst="rect">
-            <a:avLst/>
-          </a:prstGeom>
-          <a:ln>
-            <a:noFill/>
-          </a:ln>
-        </p:spPr>
-        <p:style>
-          <a:lnRef idx="2">
-            <a:schemeClr val="dk1"/>
-          </a:lnRef>
-          <a:fillRef idx="1">
-            <a:schemeClr val="lt1"/>
-          </a:fillRef>
-          <a:effectRef idx="0">
-            <a:schemeClr val="dk1"/>
-          </a:effectRef>
-          <a:fontRef idx="minor">
-            <a:schemeClr val="dk1"/>
-          </a:fontRef>
-        </p:style>
-      </p:pic>
-      <p:pic>
-        <p:nvPicPr>
-          <p:cNvPr id="8" name="Picture 7"/>
-          <p:cNvPicPr>
-            <a:picLocks noChangeAspect="1"/>
-          </p:cNvPicPr>
-          <p:nvPr userDrawn="1"/>
-        </p:nvPicPr>
-        <p:blipFill>
-          <a:blip r:embed="rId3" cstate="print">
-            <a:extLst>
-              <a:ext uri="{28A0092B-C50C-407E-A947-70E740481C1C}">
-                <a14:useLocalDpi xmlns:a14="http://schemas.microsoft.com/office/drawing/2010/main" val="0"/>
-              </a:ext>
-            </a:extLst>
-          </a:blip>
-          <a:stretch>
-            <a:fillRect/>
-          </a:stretch>
-        </p:blipFill>
-        <p:spPr>
-          <a:xfrm>
-            <a:off x="0" y="0"/>
-            <a:ext cx="9144441" cy="6858331"/>
-          </a:xfrm>
-          <a:prstGeom prst="rect">
-            <a:avLst/>
-          </a:prstGeom>
-          <a:noFill/>
-          <a:ln>
-            <a:noFill/>
-          </a:ln>
-        </p:spPr>
-      </p:pic>
-      <p:pic>
-        <p:nvPicPr>
-          <p:cNvPr id="9" name="Picture 8"/>
-          <p:cNvPicPr>
-            <a:picLocks noChangeAspect="1"/>
-          </p:cNvPicPr>
-          <p:nvPr userDrawn="1"/>
-        </p:nvPicPr>
-        <p:blipFill>
-          <a:blip r:embed="rId4" cstate="print">
-            <a:extLst>
-              <a:ext uri="{28A0092B-C50C-407E-A947-70E740481C1C}">
-                <a14:useLocalDpi xmlns:a14="http://schemas.microsoft.com/office/drawing/2010/main" val="0"/>
-              </a:ext>
-            </a:extLst>
-          </a:blip>
-          <a:stretch>
-            <a:fillRect/>
-          </a:stretch>
-        </p:blipFill>
-        <p:spPr>
-          <a:xfrm>
-            <a:off x="2514600" y="2550646"/>
-            <a:ext cx="9680189" cy="1792754"/>
-          </a:xfrm>
-          <a:prstGeom prst="rect">
-            <a:avLst/>
-          </a:prstGeom>
-        </p:spPr>
-      </p:pic>
-      <p:pic>
-        <p:nvPicPr>
-          <p:cNvPr id="10" name="Picture 9"/>
-          <p:cNvPicPr>
-            <a:picLocks noChangeAspect="1"/>
-          </p:cNvPicPr>
-          <p:nvPr userDrawn="1"/>
-        </p:nvPicPr>
-        <p:blipFill>
-          <a:blip r:embed="rId5" cstate="print">
-            <a:extLst>
-              <a:ext uri="{28A0092B-C50C-407E-A947-70E740481C1C}">
-                <a14:useLocalDpi xmlns:a14="http://schemas.microsoft.com/office/drawing/2010/main" val="0"/>
-              </a:ext>
-            </a:extLst>
-          </a:blip>
-          <a:stretch>
-            <a:fillRect/>
-          </a:stretch>
-        </p:blipFill>
-        <p:spPr>
-          <a:xfrm>
-            <a:off x="-4" y="-447353"/>
-            <a:ext cx="10744203" cy="8058153"/>
-          </a:xfrm>
-          <a:prstGeom prst="rect">
-            <a:avLst/>
-          </a:prstGeom>
-          <a:noFill/>
-          <a:ln>
-            <a:noFill/>
-          </a:ln>
-        </p:spPr>
-      </p:pic>
-      <p:sp>
-        <p:nvSpPr>
-          <p:cNvPr id="2" name="Title 1"/>
-          <p:cNvSpPr>
-            <a:spLocks noGrp="1"/>
-          </p:cNvSpPr>
-          <p:nvPr>
-            <p:ph type="ctrTitle" hasCustomPrompt="1"/>
-          </p:nvPr>
-        </p:nvSpPr>
-        <p:spPr>
-          <a:xfrm>
-            <a:off x="4572000" y="2549769"/>
-            <a:ext cx="7330831" cy="1600725"/>
-          </a:xfrm>
-        </p:spPr>
-        <p:txBody>
-          <a:bodyPr anchor="ctr">
-            <a:normAutofit/>
-          </a:bodyPr>
-          <a:lstStyle>
-            <a:lvl1pPr algn="r">
-              <a:defRPr sz="3200" b="1">
-                <a:solidFill>
-                  <a:schemeClr val="bg1"/>
-                </a:solidFill>
-                <a:latin typeface="Helvetica" panose="020B0604020202030204" pitchFamily="34" charset="0"/>
-              </a:defRPr>
-            </a:lvl1pPr>
-          </a:lstStyle>
-          <a:p>
-            <a:r>
-              <a:rPr lang="en-US" dirty="0" smtClean="0"/>
-              <a:t>Click to edit Course title</a:t>
-            </a:r>
-            <a:endParaRPr lang="en-US" dirty="0"/>
-          </a:p>
-        </p:txBody>
-      </p:sp>
-      <p:sp>
-        <p:nvSpPr>
-          <p:cNvPr id="3" name="Subtitle 2"/>
-          <p:cNvSpPr>
-            <a:spLocks noGrp="1"/>
-          </p:cNvSpPr>
-          <p:nvPr>
-            <p:ph type="subTitle" idx="1" hasCustomPrompt="1"/>
-          </p:nvPr>
-        </p:nvSpPr>
-        <p:spPr>
-          <a:xfrm>
-            <a:off x="5908431" y="4452630"/>
-            <a:ext cx="5994400" cy="343327"/>
-          </a:xfrm>
-        </p:spPr>
-        <p:txBody>
-          <a:bodyPr anchor="ctr">
-            <a:normAutofit/>
-          </a:bodyPr>
-          <a:lstStyle>
-            <a:lvl1pPr marL="0" indent="0" algn="r">
-              <a:buNone/>
-              <a:defRPr sz="1700" b="1">
-                <a:solidFill>
-                  <a:srgbClr val="1C1573"/>
-                </a:solidFill>
-                <a:latin typeface="Helvetica" panose="020B0604020202030204" pitchFamily="34" charset="0"/>
-              </a:defRPr>
-            </a:lvl1pPr>
-            <a:lvl2pPr marL="342900" indent="0" algn="ctr">
-              <a:buNone/>
-              <a:defRPr sz="1500"/>
-            </a:lvl2pPr>
-            <a:lvl3pPr marL="685800" indent="0" algn="ctr">
-              <a:buNone/>
-              <a:defRPr sz="1350"/>
-            </a:lvl3pPr>
-            <a:lvl4pPr marL="1028700" indent="0" algn="ctr">
-              <a:buNone/>
-              <a:defRPr sz="1200"/>
-            </a:lvl4pPr>
-            <a:lvl5pPr marL="1371600" indent="0" algn="ctr">
-              <a:buNone/>
-              <a:defRPr sz="1200"/>
-            </a:lvl5pPr>
-            <a:lvl6pPr marL="1714500" indent="0" algn="ctr">
-              <a:buNone/>
-              <a:defRPr sz="1200"/>
-            </a:lvl6pPr>
-            <a:lvl7pPr marL="2057400" indent="0" algn="ctr">
-              <a:buNone/>
-              <a:defRPr sz="1200"/>
-            </a:lvl7pPr>
-            <a:lvl8pPr marL="2400300" indent="0" algn="ctr">
-              <a:buNone/>
-              <a:defRPr sz="1200"/>
-            </a:lvl8pPr>
-            <a:lvl9pPr marL="2743200" indent="0" algn="ctr">
-              <a:buNone/>
-              <a:defRPr sz="1200"/>
-            </a:lvl9pPr>
-          </a:lstStyle>
-          <a:p>
-            <a:r>
-              <a:rPr lang="en-US" dirty="0" smtClean="0"/>
-              <a:t>Click to edit SME’s name</a:t>
-            </a:r>
-            <a:endParaRPr lang="en-US" dirty="0"/>
-          </a:p>
-        </p:txBody>
-      </p:sp>
-      <p:pic>
-        <p:nvPicPr>
-          <p:cNvPr id="11" name="Picture 10"/>
-          <p:cNvPicPr>
-            <a:picLocks noChangeAspect="1"/>
-          </p:cNvPicPr>
-          <p:nvPr userDrawn="1"/>
-        </p:nvPicPr>
-        <p:blipFill>
-          <a:blip r:embed="rId6" cstate="print">
-            <a:extLst>
-              <a:ext uri="{28A0092B-C50C-407E-A947-70E740481C1C}">
-                <a14:useLocalDpi xmlns:a14="http://schemas.microsoft.com/office/drawing/2010/main" val="0"/>
-              </a:ext>
-            </a:extLst>
-          </a:blip>
-          <a:stretch>
-            <a:fillRect/>
-          </a:stretch>
-        </p:blipFill>
-        <p:spPr>
-          <a:xfrm>
-            <a:off x="8523299" y="896875"/>
-            <a:ext cx="3096631" cy="1084325"/>
-          </a:xfrm>
-          <a:prstGeom prst="rect">
-            <a:avLst/>
-          </a:prstGeom>
-          <a:noFill/>
-          <a:ln>
-            <a:noFill/>
-          </a:ln>
-        </p:spPr>
-      </p:pic>
-      <p:pic>
-        <p:nvPicPr>
-          <p:cNvPr id="12" name="Picture 11"/>
-          <p:cNvPicPr>
-            <a:picLocks noChangeAspect="1"/>
-          </p:cNvPicPr>
-          <p:nvPr userDrawn="1"/>
-        </p:nvPicPr>
-        <p:blipFill>
-          <a:blip r:embed="rId7" cstate="print">
-            <a:extLst>
-              <a:ext uri="{28A0092B-C50C-407E-A947-70E740481C1C}">
-                <a14:useLocalDpi xmlns:a14="http://schemas.microsoft.com/office/drawing/2010/main" val="0"/>
-              </a:ext>
-            </a:extLst>
-          </a:blip>
-          <a:stretch>
-            <a:fillRect/>
-          </a:stretch>
-        </p:blipFill>
-        <p:spPr>
-          <a:xfrm>
-            <a:off x="6778116" y="4800600"/>
-            <a:ext cx="5124715" cy="21336"/>
-          </a:xfrm>
-          <a:prstGeom prst="rect">
-            <a:avLst/>
-          </a:prstGeom>
-        </p:spPr>
-      </p:pic>
-      <p:sp>
-        <p:nvSpPr>
-          <p:cNvPr id="22" name="Text Placeholder 21"/>
-          <p:cNvSpPr>
-            <a:spLocks noGrp="1"/>
-          </p:cNvSpPr>
-          <p:nvPr>
-            <p:ph type="body" sz="quarter" idx="14"/>
-          </p:nvPr>
-        </p:nvSpPr>
-        <p:spPr>
-          <a:xfrm>
-            <a:off x="5189412" y="4826977"/>
-            <a:ext cx="6713419" cy="1108563"/>
-          </a:xfrm>
-        </p:spPr>
-        <p:txBody>
-          <a:bodyPr>
-            <a:normAutofit/>
-          </a:bodyPr>
-          <a:lstStyle>
-            <a:lvl1pPr marL="0" indent="0" algn="r">
-              <a:spcBef>
-                <a:spcPts val="0"/>
-              </a:spcBef>
-              <a:buNone/>
-              <a:defRPr sz="1700">
-                <a:solidFill>
-                  <a:srgbClr val="1C1573"/>
-                </a:solidFill>
-                <a:latin typeface="Helvetica" panose="020B0604020202030204" pitchFamily="34" charset="0"/>
-              </a:defRPr>
-            </a:lvl1pPr>
-          </a:lstStyle>
-          <a:p>
-            <a:pPr lvl="0"/>
-            <a:r>
-              <a:rPr lang="en-US" smtClean="0"/>
-              <a:t>Click to edit Master text styles</a:t>
-            </a:r>
-          </a:p>
-          <a:p>
-            <a:pPr lvl="1"/>
-            <a:r>
-              <a:rPr lang="en-US" smtClean="0"/>
-              <a:t>Second level</a:t>
-            </a:r>
-          </a:p>
-        </p:txBody>
-      </p:sp>
-    </p:spTree>
-    <p:extLst>
-      <p:ext uri="{BB962C8B-B14F-4D97-AF65-F5344CB8AC3E}">
-        <p14:creationId xmlns:p14="http://schemas.microsoft.com/office/powerpoint/2010/main" val="1661812112"/>
-      </p:ext>
-    </p:extLst>
-  </p:cSld>
-  <p:clrMapOvr>
-    <a:masterClrMapping/>
-  </p:clrMapOvr>
-  <p:timing>
-    <p:tnLst>
-      <p:par>
-        <p:cTn id="1" dur="indefinite" restart="never" nodeType="tmRoot">
-          <p:childTnLst>
-            <p:seq concurrent="1" nextAc="seek">
-              <p:cTn id="2" dur="indefinite" nodeType="mainSeq">
-                <p:childTnLst>
-                  <p:par>
-                    <p:cTn id="3" fill="hold">
-                      <p:stCondLst>
-                        <p:cond delay="indefinite"/>
-                        <p:cond evt="onBegin" delay="0">
-                          <p:tn val="2"/>
-                        </p:cond>
-                      </p:stCondLst>
-                      <p:childTnLst>
-                        <p:par>
-                          <p:cTn id="4" fill="hold">
-                            <p:stCondLst>
-                              <p:cond delay="0"/>
-                            </p:stCondLst>
-                            <p:childTnLst>
-                              <p:par>
-                                <p:cTn id="5" presetID="6" presetClass="entr" presetSubtype="16" fill="hold" nodeType="afterEffect">
-                                  <p:stCondLst>
-                                    <p:cond delay="0"/>
-                                  </p:stCondLst>
-                                  <p:childTnLst>
-                                    <p:set>
-                                      <p:cBhvr>
-                                        <p:cTn id="6" dur="1" fill="hold">
-                                          <p:stCondLst>
-                                            <p:cond delay="0"/>
-                                          </p:stCondLst>
-                                        </p:cTn>
-                                        <p:tgtEl>
-                                          <p:spTgt spid="8"/>
-                                        </p:tgtEl>
-                                        <p:attrNameLst>
-                                          <p:attrName>style.visibility</p:attrName>
-                                        </p:attrNameLst>
-                                      </p:cBhvr>
-                                      <p:to>
-                                        <p:strVal val="visible"/>
-                                      </p:to>
-                                    </p:set>
-                                    <p:animEffect transition="in" filter="circle(in)">
-                                      <p:cBhvr>
-                                        <p:cTn id="7" dur="1200"/>
-                                        <p:tgtEl>
-                                          <p:spTgt spid="8"/>
-                                        </p:tgtEl>
-                                      </p:cBhvr>
-                                    </p:animEffect>
-                                  </p:childTnLst>
-                                </p:cTn>
-                              </p:par>
-                            </p:childTnLst>
-                          </p:cTn>
-                        </p:par>
-                        <p:par>
-                          <p:cTn id="8" fill="hold">
-                            <p:stCondLst>
-                              <p:cond delay="1200"/>
-                            </p:stCondLst>
-                            <p:childTnLst>
-                              <p:par>
-                                <p:cTn id="9" presetID="20" presetClass="entr" presetSubtype="0" fill="hold" nodeType="afterEffect">
-                                  <p:stCondLst>
-                                    <p:cond delay="0"/>
-                                  </p:stCondLst>
-                                  <p:childTnLst>
-                                    <p:set>
-                                      <p:cBhvr>
-                                        <p:cTn id="10" dur="1" fill="hold">
-                                          <p:stCondLst>
-                                            <p:cond delay="0"/>
-                                          </p:stCondLst>
-                                        </p:cTn>
-                                        <p:tgtEl>
-                                          <p:spTgt spid="10"/>
-                                        </p:tgtEl>
-                                        <p:attrNameLst>
-                                          <p:attrName>style.visibility</p:attrName>
-                                        </p:attrNameLst>
-                                      </p:cBhvr>
-                                      <p:to>
-                                        <p:strVal val="visible"/>
-                                      </p:to>
-                                    </p:set>
-                                    <p:animEffect transition="in" filter="wedge">
-                                      <p:cBhvr>
-                                        <p:cTn id="11" dur="1300"/>
-                                        <p:tgtEl>
-                                          <p:spTgt spid="10"/>
-                                        </p:tgtEl>
-                                      </p:cBhvr>
-                                    </p:animEffect>
-                                  </p:childTnLst>
-                                </p:cTn>
-                              </p:par>
-                            </p:childTnLst>
-                          </p:cTn>
-                        </p:par>
-                        <p:par>
-                          <p:cTn id="12" fill="hold">
-                            <p:stCondLst>
-                              <p:cond delay="2500"/>
-                            </p:stCondLst>
-                            <p:childTnLst>
-                              <p:par>
-                                <p:cTn id="13" presetID="10" presetClass="entr" presetSubtype="0" fill="hold" nodeType="afterEffect">
-                                  <p:stCondLst>
-                                    <p:cond delay="0"/>
-                                  </p:stCondLst>
-                                  <p:childTnLst>
-                                    <p:set>
-                                      <p:cBhvr>
-                                        <p:cTn id="14" dur="1" fill="hold">
-                                          <p:stCondLst>
-                                            <p:cond delay="0"/>
-                                          </p:stCondLst>
-                                        </p:cTn>
-                                        <p:tgtEl>
-                                          <p:spTgt spid="11"/>
-                                        </p:tgtEl>
-                                        <p:attrNameLst>
-                                          <p:attrName>style.visibility</p:attrName>
-                                        </p:attrNameLst>
-                                      </p:cBhvr>
-                                      <p:to>
-                                        <p:strVal val="visible"/>
-                                      </p:to>
-                                    </p:set>
-                                    <p:animEffect transition="in" filter="fade">
-                                      <p:cBhvr>
-                                        <p:cTn id="15" dur="500"/>
-                                        <p:tgtEl>
-                                          <p:spTgt spid="11"/>
-                                        </p:tgtEl>
-                                      </p:cBhvr>
-                                    </p:animEffect>
-                                  </p:childTnLst>
-                                </p:cTn>
-                              </p:par>
-                            </p:childTnLst>
-                          </p:cTn>
-                        </p:par>
-                        <p:par>
-                          <p:cTn id="16" fill="hold">
-                            <p:stCondLst>
-                              <p:cond delay="3000"/>
-                            </p:stCondLst>
-                            <p:childTnLst>
-                              <p:par>
-                                <p:cTn id="17" presetID="22" presetClass="entr" presetSubtype="8" fill="hold" nodeType="afterEffect">
-                                  <p:stCondLst>
-                                    <p:cond delay="0"/>
-                                  </p:stCondLst>
-                                  <p:childTnLst>
-                                    <p:set>
-                                      <p:cBhvr>
-                                        <p:cTn id="18" dur="1" fill="hold">
-                                          <p:stCondLst>
-                                            <p:cond delay="0"/>
-                                          </p:stCondLst>
-                                        </p:cTn>
-                                        <p:tgtEl>
-                                          <p:spTgt spid="9"/>
-                                        </p:tgtEl>
-                                        <p:attrNameLst>
-                                          <p:attrName>style.visibility</p:attrName>
-                                        </p:attrNameLst>
-                                      </p:cBhvr>
-                                      <p:to>
-                                        <p:strVal val="visible"/>
-                                      </p:to>
-                                    </p:set>
-                                    <p:animEffect transition="in" filter="wipe(left)">
-                                      <p:cBhvr>
-                                        <p:cTn id="19" dur="500"/>
-                                        <p:tgtEl>
-                                          <p:spTgt spid="9"/>
-                                        </p:tgtEl>
-                                      </p:cBhvr>
-                                    </p:animEffect>
-                                  </p:childTnLst>
-                                </p:cTn>
-                              </p:par>
-                            </p:childTnLst>
-                          </p:cTn>
-                        </p:par>
-                        <p:par>
-                          <p:cTn id="20" fill="hold">
-                            <p:stCondLst>
-                              <p:cond delay="3500"/>
-                            </p:stCondLst>
-                            <p:childTnLst>
-                              <p:par>
-                                <p:cTn id="21" presetID="10" presetClass="entr" presetSubtype="0" fill="hold" nodeType="afterEffect">
-                                  <p:stCondLst>
-                                    <p:cond delay="0"/>
-                                  </p:stCondLst>
-                                  <p:childTnLst>
-                                    <p:set>
-                                      <p:cBhvr>
-                                        <p:cTn id="22" dur="1" fill="hold">
-                                          <p:stCondLst>
-                                            <p:cond delay="0"/>
-                                          </p:stCondLst>
-                                        </p:cTn>
-                                        <p:tgtEl>
-                                          <p:spTgt spid="12"/>
-                                        </p:tgtEl>
-                                        <p:attrNameLst>
-                                          <p:attrName>style.visibility</p:attrName>
-                                        </p:attrNameLst>
-                                      </p:cBhvr>
-                                      <p:to>
-                                        <p:strVal val="visible"/>
-                                      </p:to>
-                                    </p:set>
-                                    <p:animEffect transition="in" filter="fade">
-                                      <p:cBhvr>
-                                        <p:cTn id="23" dur="500"/>
-                                        <p:tgtEl>
-                                          <p:spTgt spid="12"/>
-                                        </p:tgtEl>
-                                      </p:cBhvr>
-                                    </p:animEffect>
-                                  </p:childTnLst>
-                                </p:cTn>
-                              </p:par>
-                              <p:par>
-                                <p:cTn id="24" presetID="10" presetClass="entr" presetSubtype="0" fill="hold" grpId="0" nodeType="withEffect">
-                                  <p:stCondLst>
-                                    <p:cond delay="0"/>
-                                  </p:stCondLst>
-                                  <p:childTnLst>
-                                    <p:set>
-                                      <p:cBhvr>
-                                        <p:cTn id="25" dur="1" fill="hold">
-                                          <p:stCondLst>
-                                            <p:cond delay="0"/>
-                                          </p:stCondLst>
-                                        </p:cTn>
-                                        <p:tgtEl>
-                                          <p:spTgt spid="2"/>
-                                        </p:tgtEl>
-                                        <p:attrNameLst>
-                                          <p:attrName>style.visibility</p:attrName>
-                                        </p:attrNameLst>
-                                      </p:cBhvr>
-                                      <p:to>
-                                        <p:strVal val="visible"/>
-                                      </p:to>
-                                    </p:set>
-                                    <p:animEffect transition="in" filter="fade">
-                                      <p:cBhvr>
-                                        <p:cTn id="26" dur="500"/>
-                                        <p:tgtEl>
-                                          <p:spTgt spid="2"/>
-                                        </p:tgtEl>
-                                      </p:cBhvr>
-                                    </p:animEffect>
-                                  </p:childTnLst>
-                                </p:cTn>
-                              </p:par>
-                              <p:par>
-                                <p:cTn id="27" presetID="10" presetClass="entr" presetSubtype="0" fill="hold" grpId="0" nodeType="withEffect">
-                                  <p:stCondLst>
-                                    <p:cond delay="0"/>
-                                  </p:stCondLst>
-                                  <p:childTnLst>
-                                    <p:set>
-                                      <p:cBhvr>
-                                        <p:cTn id="28" dur="1" fill="hold">
-                                          <p:stCondLst>
-                                            <p:cond delay="0"/>
-                                          </p:stCondLst>
-                                        </p:cTn>
-                                        <p:tgtEl>
-                                          <p:spTgt spid="3">
-                                            <p:txEl>
-                                              <p:pRg st="0" end="0"/>
-                                            </p:txEl>
-                                          </p:spTgt>
-                                        </p:tgtEl>
-                                        <p:attrNameLst>
-                                          <p:attrName>style.visibility</p:attrName>
-                                        </p:attrNameLst>
-                                      </p:cBhvr>
-                                      <p:to>
-                                        <p:strVal val="visible"/>
-                                      </p:to>
-                                    </p:set>
-                                    <p:animEffect transition="in" filter="fade">
-                                      <p:cBhvr>
-                                        <p:cTn id="29" dur="500"/>
-                                        <p:tgtEl>
-                                          <p:spTgt spid="3">
-                                            <p:txEl>
-                                              <p:pRg st="0" end="0"/>
-                                            </p:txEl>
-                                          </p:spTgt>
-                                        </p:tgtEl>
-                                      </p:cBhvr>
-                                    </p:animEffect>
-                                  </p:childTnLst>
-                                </p:cTn>
-                              </p:par>
-                              <p:par>
-                                <p:cTn id="30" presetID="10" presetClass="entr" presetSubtype="0" fill="hold" grpId="0" nodeType="withEffect">
-                                  <p:stCondLst>
-                                    <p:cond delay="0"/>
-                                  </p:stCondLst>
-                                  <p:childTnLst>
-                                    <p:set>
-                                      <p:cBhvr>
-                                        <p:cTn id="31" dur="1" fill="hold">
-                                          <p:stCondLst>
-                                            <p:cond delay="0"/>
-                                          </p:stCondLst>
-                                        </p:cTn>
-                                        <p:tgtEl>
-                                          <p:spTgt spid="22">
-                                            <p:txEl>
-                                              <p:pRg st="0" end="0"/>
-                                            </p:txEl>
-                                          </p:spTgt>
-                                        </p:tgtEl>
-                                        <p:attrNameLst>
-                                          <p:attrName>style.visibility</p:attrName>
-                                        </p:attrNameLst>
-                                      </p:cBhvr>
-                                      <p:to>
-                                        <p:strVal val="visible"/>
-                                      </p:to>
-                                    </p:set>
-                                    <p:animEffect transition="in" filter="fade">
-                                      <p:cBhvr>
-                                        <p:cTn id="32" dur="500"/>
-                                        <p:tgtEl>
-                                          <p:spTgt spid="22">
-                                            <p:txEl>
-                                              <p:pRg st="0" end="0"/>
-                                            </p:txEl>
-                                          </p:spTgt>
-                                        </p:tgtEl>
-                                      </p:cBhvr>
-                                    </p:animEffect>
-                                  </p:childTnLst>
-                                </p:cTn>
-                              </p:par>
-                              <p:par>
-                                <p:cTn id="33" presetID="10" presetClass="entr" presetSubtype="0" fill="hold" grpId="0" nodeType="withEffect">
-                                  <p:stCondLst>
-                                    <p:cond delay="0"/>
-                                  </p:stCondLst>
-                                  <p:childTnLst>
-                                    <p:set>
-                                      <p:cBhvr>
-                                        <p:cTn id="34" dur="1" fill="hold">
-                                          <p:stCondLst>
-                                            <p:cond delay="0"/>
-                                          </p:stCondLst>
-                                        </p:cTn>
-                                        <p:tgtEl>
-                                          <p:spTgt spid="22">
-                                            <p:txEl>
-                                              <p:pRg st="1" end="1"/>
-                                            </p:txEl>
-                                          </p:spTgt>
-                                        </p:tgtEl>
-                                        <p:attrNameLst>
-                                          <p:attrName>style.visibility</p:attrName>
-                                        </p:attrNameLst>
-                                      </p:cBhvr>
-                                      <p:to>
-                                        <p:strVal val="visible"/>
-                                      </p:to>
-                                    </p:set>
-                                    <p:animEffect transition="in" filter="fade">
-                                      <p:cBhvr>
-                                        <p:cTn id="35" dur="500"/>
-                                        <p:tgtEl>
-                                          <p:spTgt spid="22">
-                                            <p:txEl>
-                                              <p:pRg st="1" end="1"/>
-                                            </p:txEl>
-                                          </p:spTgt>
-                                        </p:tgtEl>
-                                      </p:cBhvr>
-                                    </p:animEffect>
-                                  </p:childTnLst>
-                                </p:cTn>
-                              </p:par>
-                            </p:childTnLst>
-                          </p:cTn>
-                        </p:par>
-                      </p:childTnLst>
-                    </p:cTn>
-                  </p:par>
-                </p:childTnLst>
-              </p:cTn>
-              <p:prevCondLst>
-                <p:cond evt="onPrev" delay="0">
-                  <p:tgtEl>
-                    <p:sldTgt/>
-                  </p:tgtEl>
-                </p:cond>
-              </p:prevCondLst>
-              <p:nextCondLst>
-                <p:cond evt="onNext" delay="0">
-                  <p:tgtEl>
-                    <p:sldTgt/>
-                  </p:tgtEl>
-                </p:cond>
-              </p:nextCondLst>
-            </p:seq>
-          </p:childTnLst>
-        </p:cTn>
-      </p:par>
-    </p:tnLst>
-    <p:bldLst>
-      <p:bldP spid="2" grpId="0"/>
-      <p:bldP spid="3" grpId="0" build="p">
-        <p:tmplLst>
-          <p:tmpl lvl="1">
-            <p:tnLst>
-              <p:par>
-                <p:cTn presetID="10" presetClass="entr" presetSubtype="0" fill="hold" nodeType="withEffect">
-                  <p:stCondLst>
-                    <p:cond delay="0"/>
-                  </p:stCondLst>
-                  <p:childTnLst>
-                    <p:set>
-                      <p:cBhvr>
-                        <p:cTn dur="1" fill="hold">
-                          <p:stCondLst>
-                            <p:cond delay="0"/>
-                          </p:stCondLst>
-                        </p:cTn>
-                        <p:tgtEl>
-                          <p:spTgt spid="3"/>
-                        </p:tgtEl>
-                        <p:attrNameLst>
-                          <p:attrName>style.visibility</p:attrName>
-                        </p:attrNameLst>
-                      </p:cBhvr>
-                      <p:to>
-                        <p:strVal val="visible"/>
-                      </p:to>
-                    </p:set>
-                    <p:animEffect transition="in" filter="fade">
-                      <p:cBhvr>
-                        <p:cTn dur="500"/>
-                        <p:tgtEl>
-                          <p:spTgt spid="3"/>
-                        </p:tgtEl>
-                      </p:cBhvr>
-                    </p:animEffect>
-                  </p:childTnLst>
-                </p:cTn>
-              </p:par>
-            </p:tnLst>
-          </p:tmpl>
-        </p:tmplLst>
-      </p:bldP>
-      <p:bldP spid="22" grpId="0" build="p">
-        <p:tmplLst>
-          <p:tmpl lvl="1">
-            <p:tnLst>
-              <p:par>
-                <p:cTn presetID="10" presetClass="entr" presetSubtype="0" fill="hold" nodeType="withEffect">
-                  <p:stCondLst>
-                    <p:cond delay="0"/>
-                  </p:stCondLst>
-                  <p:childTnLst>
-                    <p:set>
-                      <p:cBhvr>
-                        <p:cTn dur="1" fill="hold">
-                          <p:stCondLst>
-                            <p:cond delay="0"/>
-                          </p:stCondLst>
-                        </p:cTn>
-                        <p:tgtEl>
-                          <p:spTgt spid="22"/>
-                        </p:tgtEl>
-                        <p:attrNameLst>
-                          <p:attrName>style.visibility</p:attrName>
-                        </p:attrNameLst>
-                      </p:cBhvr>
-                      <p:to>
-                        <p:strVal val="visible"/>
-                      </p:to>
-                    </p:set>
-                    <p:animEffect transition="in" filter="fade">
-                      <p:cBhvr>
-                        <p:cTn dur="500"/>
-                        <p:tgtEl>
-                          <p:spTgt spid="22"/>
-                        </p:tgtEl>
-                      </p:cBhvr>
-                    </p:animEffect>
-                  </p:childTnLst>
-                </p:cTn>
-              </p:par>
-            </p:tnLst>
-          </p:tmpl>
-        </p:tmplLst>
-      </p:bldP>
-    </p:bldLst>
-  </p:timing>
-</p:sldLayout>
-</file>
-
-<file path=ppt/slideLayouts/slideLayout2.xml><?xml version="1.0" encoding="utf-8"?>
 <p:sldLayout xmlns:a="http://schemas.openxmlformats.org/drawingml/2006/main" xmlns:r="http://schemas.openxmlformats.org/officeDocument/2006/relationships" xmlns:p="http://schemas.openxmlformats.org/presentationml/2006/main" preserve="1" userDrawn="1">
   <p:cSld name="Section Header">
     <p:spTree>
@@ -20027,10 +18954,9 @@
           <a:p>
             <a:pPr algn="ctr"/>
             <a:r>
-              <a:rPr lang="en-US" sz="3600" dirty="0" smtClean="0"/>
+              <a:rPr lang="en-US" sz="3600" dirty="0"/>
               <a:t>Click to edit Session title</a:t>
             </a:r>
-            <a:endParaRPr lang="en-US" sz="3600" dirty="0"/>
           </a:p>
         </p:txBody>
       </p:sp>
@@ -20244,7 +19170,7 @@
 </p:sldLayout>
 </file>
 
-<file path=ppt/slideLayouts/slideLayout3.xml><?xml version="1.0" encoding="utf-8"?>
+<file path=ppt/slideLayouts/slideLayout2.xml><?xml version="1.0" encoding="utf-8"?>
 <p:sldLayout xmlns:a="http://schemas.openxmlformats.org/drawingml/2006/main" xmlns:r="http://schemas.openxmlformats.org/officeDocument/2006/relationships" xmlns:p="http://schemas.openxmlformats.org/presentationml/2006/main" userDrawn="1">
   <p:cSld name="1_Title and Content">
     <p:spTree>
@@ -20383,10 +19309,9 @@
           </a:lstStyle>
           <a:p>
             <a:r>
-              <a:rPr lang="en-US" smtClean="0"/>
+              <a:rPr lang="en-US"/>
               <a:t>Click to edit Master title style</a:t>
             </a:r>
-            <a:endParaRPr lang="en-US"/>
           </a:p>
         </p:txBody>
       </p:sp>
@@ -20438,35 +19363,35 @@
           <a:p>
             <a:pPr lvl="0"/>
             <a:r>
-              <a:rPr lang="en-US" smtClean="0"/>
+              <a:rPr lang="en-US"/>
               <a:t>Click to edit Master text styles</a:t>
             </a:r>
           </a:p>
           <a:p>
             <a:pPr lvl="1"/>
             <a:r>
-              <a:rPr lang="en-US" smtClean="0"/>
+              <a:rPr lang="en-US"/>
               <a:t>Second level</a:t>
             </a:r>
           </a:p>
           <a:p>
             <a:pPr lvl="2"/>
             <a:r>
-              <a:rPr lang="en-US" smtClean="0"/>
+              <a:rPr lang="en-US"/>
               <a:t>Third level</a:t>
             </a:r>
           </a:p>
           <a:p>
             <a:pPr lvl="3"/>
             <a:r>
-              <a:rPr lang="en-US" smtClean="0"/>
+              <a:rPr lang="en-US"/>
               <a:t>Fourth level</a:t>
             </a:r>
           </a:p>
           <a:p>
             <a:pPr lvl="4"/>
             <a:r>
-              <a:rPr lang="en-US" smtClean="0"/>
+              <a:rPr lang="en-US"/>
               <a:t>Fifth level</a:t>
             </a:r>
             <a:endParaRPr lang="en-US" dirty="0"/>
@@ -20539,7 +19464,7 @@
           <a:p>
             <a:pPr lvl="0"/>
             <a:r>
-              <a:rPr lang="en-US" smtClean="0"/>
+              <a:rPr lang="en-US"/>
               <a:t>Click to edit Master text styles</a:t>
             </a:r>
           </a:p>
@@ -20555,17 +19480,10 @@
   <p:clrMapOvr>
     <a:masterClrMapping/>
   </p:clrMapOvr>
-  <p:timing>
-    <p:tnLst>
-      <p:par>
-        <p:cTn id="1" dur="indefinite" restart="never" nodeType="tmRoot"/>
-      </p:par>
-    </p:tnLst>
-  </p:timing>
 </p:sldLayout>
 </file>
 
-<file path=ppt/slideLayouts/slideLayout4.xml><?xml version="1.0" encoding="utf-8"?>
+<file path=ppt/slideLayouts/slideLayout3.xml><?xml version="1.0" encoding="utf-8"?>
 <p:sldLayout xmlns:a="http://schemas.openxmlformats.org/drawingml/2006/main" xmlns:r="http://schemas.openxmlformats.org/officeDocument/2006/relationships" xmlns:p="http://schemas.openxmlformats.org/presentationml/2006/main" type="secHead" preserve="1">
   <p:cSld name="1_Section Header">
     <p:spTree>
@@ -20645,7 +19563,7 @@
           </a:lstStyle>
           <a:p>
             <a:r>
-              <a:rPr lang="en-US" smtClean="0"/>
+              <a:rPr lang="en-US"/>
               <a:t>Click to edit Master title style</a:t>
             </a:r>
             <a:endParaRPr lang="en-US" dirty="0"/>
@@ -20767,7 +19685,7 @@
           <a:p>
             <a:pPr lvl="0"/>
             <a:r>
-              <a:rPr lang="en-US" smtClean="0"/>
+              <a:rPr lang="en-US"/>
               <a:t>Click to edit Master text styles</a:t>
             </a:r>
           </a:p>
@@ -20813,13 +19731,6 @@
   <p:clrMapOvr>
     <a:masterClrMapping/>
   </p:clrMapOvr>
-  <p:timing>
-    <p:tnLst>
-      <p:par>
-        <p:cTn id="1" dur="indefinite" restart="never" nodeType="tmRoot"/>
-      </p:par>
-    </p:tnLst>
-  </p:timing>
 </p:sldLayout>
 </file>
 
@@ -20871,7 +19782,7 @@
           <a:lstStyle/>
           <a:p>
             <a:r>
-              <a:rPr lang="en-US" smtClean="0"/>
+              <a:rPr lang="en-US"/>
               <a:t>Click to edit Master title style</a:t>
             </a:r>
             <a:endParaRPr lang="en-US" dirty="0"/>
@@ -20905,35 +19816,35 @@
           <a:p>
             <a:pPr lvl="0"/>
             <a:r>
-              <a:rPr lang="en-US" smtClean="0"/>
+              <a:rPr lang="en-US"/>
               <a:t>Click to edit Master text styles</a:t>
             </a:r>
           </a:p>
           <a:p>
             <a:pPr lvl="1"/>
             <a:r>
-              <a:rPr lang="en-US" smtClean="0"/>
+              <a:rPr lang="en-US"/>
               <a:t>Second level</a:t>
             </a:r>
           </a:p>
           <a:p>
             <a:pPr lvl="2"/>
             <a:r>
-              <a:rPr lang="en-US" smtClean="0"/>
+              <a:rPr lang="en-US"/>
               <a:t>Third level</a:t>
             </a:r>
           </a:p>
           <a:p>
             <a:pPr lvl="3"/>
             <a:r>
-              <a:rPr lang="en-US" smtClean="0"/>
+              <a:rPr lang="en-US"/>
               <a:t>Fourth level</a:t>
             </a:r>
           </a:p>
           <a:p>
             <a:pPr lvl="4"/>
             <a:r>
-              <a:rPr lang="en-US" smtClean="0"/>
+              <a:rPr lang="en-US"/>
               <a:t>Fifth level</a:t>
             </a:r>
             <a:endParaRPr lang="en-US" dirty="0"/>
@@ -20949,18 +19860,10 @@
   </p:cSld>
   <p:clrMap bg1="lt1" tx1="dk1" bg2="lt2" tx2="dk2" accent1="accent1" accent2="accent2" accent3="accent3" accent4="accent4" accent5="accent5" accent6="accent6" hlink="hlink" folHlink="folHlink"/>
   <p:sldLayoutIdLst>
-    <p:sldLayoutId id="2147483738" r:id="rId1"/>
-    <p:sldLayoutId id="2147483729" r:id="rId2"/>
-    <p:sldLayoutId id="2147483739" r:id="rId3"/>
-    <p:sldLayoutId id="2147483740" r:id="rId4"/>
+    <p:sldLayoutId id="2147483729" r:id="rId1"/>
+    <p:sldLayoutId id="2147483739" r:id="rId2"/>
+    <p:sldLayoutId id="2147483740" r:id="rId3"/>
   </p:sldLayoutIdLst>
-  <p:timing>
-    <p:tnLst>
-      <p:par>
-        <p:cTn id="1" dur="indefinite" restart="never" nodeType="tmRoot"/>
-      </p:par>
-    </p:tnLst>
-  </p:timing>
   <p:txStyles>
     <p:titleStyle>
       <a:lvl1pPr algn="l" defTabSz="914400" rtl="0" eaLnBrk="1" latinLnBrk="0" hangingPunct="1">
@@ -21263,40 +20166,12 @@
       </p:grpSpPr>
       <p:sp>
         <p:nvSpPr>
-          <p:cNvPr id="5" name="Title 4"/>
+          <p:cNvPr id="2" name="Title 1"/>
           <p:cNvSpPr>
             <a:spLocks noGrp="1"/>
           </p:cNvSpPr>
           <p:nvPr>
-            <p:ph type="ctrTitle"/>
-          </p:nvPr>
-        </p:nvSpPr>
-        <p:spPr>
-          <a:xfrm>
-            <a:off x="4572000" y="2549769"/>
-            <a:ext cx="7330831" cy="1793631"/>
-          </a:xfrm>
-        </p:spPr>
-        <p:txBody>
-          <a:bodyPr/>
-          <a:lstStyle/>
-          <a:p>
-            <a:r>
-              <a:rPr lang="en-US" dirty="0" smtClean="0"/>
-              <a:t>Introduction to DevOps</a:t>
-            </a:r>
-            <a:endParaRPr lang="en-US" dirty="0"/>
-          </a:p>
-        </p:txBody>
-      </p:sp>
-      <p:sp>
-        <p:nvSpPr>
-          <p:cNvPr id="6" name="Subtitle 5"/>
-          <p:cNvSpPr>
-            <a:spLocks noGrp="1"/>
-          </p:cNvSpPr>
-          <p:nvPr>
-            <p:ph type="subTitle" idx="1"/>
+            <p:ph type="title"/>
           </p:nvPr>
         </p:nvSpPr>
         <p:spPr/>
@@ -21305,16 +20180,95 @@
           <a:lstStyle/>
           <a:p>
             <a:r>
-              <a:rPr lang="en-US" dirty="0" smtClean="0"/>
-              <a:t>Sonika Rathi</a:t>
+              <a:rPr lang="en-US" dirty="0"/>
+              <a:t>DevOps Basics</a:t>
             </a:r>
+          </a:p>
+        </p:txBody>
+      </p:sp>
+      <p:sp>
+        <p:nvSpPr>
+          <p:cNvPr id="3" name="Text Placeholder 2"/>
+          <p:cNvSpPr>
+            <a:spLocks noGrp="1"/>
+          </p:cNvSpPr>
+          <p:nvPr>
+            <p:ph type="body" sz="quarter" idx="13"/>
+          </p:nvPr>
+        </p:nvSpPr>
+        <p:spPr>
+          <a:xfrm>
+            <a:off x="857739" y="1600201"/>
+            <a:ext cx="10160000" cy="2971799"/>
+          </a:xfrm>
+        </p:spPr>
+        <p:txBody>
+          <a:bodyPr>
+            <a:normAutofit/>
+          </a:bodyPr>
+          <a:lstStyle/>
+          <a:p>
+            <a:r>
+              <a:rPr lang="en-US" dirty="0"/>
+              <a:t>A clipped compound of Development and Operations</a:t>
+            </a:r>
+          </a:p>
+          <a:p>
+            <a:r>
+              <a:rPr lang="en-US" dirty="0"/>
+              <a:t>Buzzword</a:t>
+            </a:r>
+          </a:p>
+          <a:p>
+            <a:r>
+              <a:rPr lang="en-US" dirty="0"/>
+              <a:t>Innovation for automation (pillar of DevOps)</a:t>
+            </a:r>
+          </a:p>
+          <a:p>
+            <a:r>
+              <a:rPr lang="en-US" dirty="0"/>
+              <a:t>DevOps is an approach based on lean and agile principles</a:t>
+            </a:r>
+          </a:p>
+          <a:p>
+            <a:r>
+              <a:rPr lang="en-US" dirty="0"/>
+              <a:t>There are more tangential DevOps Initiative</a:t>
+            </a:r>
+          </a:p>
+          <a:p>
+            <a:pPr lvl="1"/>
+            <a:r>
+              <a:rPr lang="en-US" dirty="0" err="1"/>
+              <a:t>WinOps</a:t>
+            </a:r>
+            <a:endParaRPr lang="en-US" dirty="0"/>
+          </a:p>
+          <a:p>
+            <a:pPr lvl="1"/>
+            <a:r>
+              <a:rPr lang="en-US" dirty="0" err="1"/>
+              <a:t>DevSecOps</a:t>
+            </a:r>
+            <a:endParaRPr lang="en-US" dirty="0"/>
+          </a:p>
+          <a:p>
+            <a:pPr lvl="1"/>
+            <a:r>
+              <a:rPr lang="en-US" dirty="0" err="1"/>
+              <a:t>BizDevOps</a:t>
+            </a:r>
+            <a:endParaRPr lang="en-US" dirty="0"/>
+          </a:p>
+          <a:p>
             <a:endParaRPr lang="en-US" dirty="0"/>
           </a:p>
         </p:txBody>
       </p:sp>
       <p:sp>
         <p:nvSpPr>
-          <p:cNvPr id="7" name="Text Placeholder 6"/>
+          <p:cNvPr id="4" name="Text Placeholder 3"/>
           <p:cNvSpPr>
             <a:spLocks noGrp="1"/>
           </p:cNvSpPr>
@@ -21328,44 +20282,26 @@
           <a:lstStyle/>
           <a:p>
             <a:r>
-              <a:rPr lang="en-US" dirty="0" smtClean="0"/>
-              <a:t>Assistant Professor</a:t>
+              <a:rPr lang="en-US" dirty="0"/>
+              <a:t>Introduction</a:t>
             </a:r>
-          </a:p>
-          <a:p>
-            <a:r>
-              <a:rPr lang="en-US" dirty="0" smtClean="0"/>
-              <a:t>BITS </a:t>
-            </a:r>
-            <a:r>
-              <a:rPr lang="en-US" dirty="0" err="1" smtClean="0"/>
-              <a:t>Pilani</a:t>
-            </a:r>
-            <a:endParaRPr lang="en-US" dirty="0"/>
           </a:p>
         </p:txBody>
       </p:sp>
     </p:spTree>
     <p:extLst>
       <p:ext uri="{BB962C8B-B14F-4D97-AF65-F5344CB8AC3E}">
-        <p14:creationId xmlns:p14="http://schemas.microsoft.com/office/powerpoint/2010/main" val="379725488"/>
+        <p14:creationId xmlns:p14="http://schemas.microsoft.com/office/powerpoint/2010/main" val="2457796145"/>
       </p:ext>
     </p:extLst>
   </p:cSld>
   <p:clrMapOvr>
     <a:masterClrMapping/>
   </p:clrMapOvr>
-  <p:timing>
-    <p:tnLst>
-      <p:par>
-        <p:cTn id="1" dur="indefinite" restart="never" nodeType="tmRoot"/>
-      </p:par>
-    </p:tnLst>
-  </p:timing>
 </p:sld>
 </file>
 
-<file path=ppt/slides/slide10.xml><?xml version="1.0" encoding="utf-8"?>
+<file path=ppt/slides/slide2.xml><?xml version="1.0" encoding="utf-8"?>
 <p:sld xmlns:a="http://schemas.openxmlformats.org/drawingml/2006/main" xmlns:r="http://schemas.openxmlformats.org/officeDocument/2006/relationships" xmlns:p="http://schemas.openxmlformats.org/presentationml/2006/main">
   <p:cSld>
     <p:spTree>
@@ -21398,10 +20334,871 @@
           <a:lstStyle/>
           <a:p>
             <a:r>
-              <a:rPr lang="en-US" dirty="0" smtClean="0"/>
+              <a:rPr lang="en-US" dirty="0"/>
               <a:t>DevOps Basics</a:t>
             </a:r>
+          </a:p>
+        </p:txBody>
+      </p:sp>
+      <p:sp>
+        <p:nvSpPr>
+          <p:cNvPr id="3" name="Text Placeholder 2"/>
+          <p:cNvSpPr>
+            <a:spLocks noGrp="1"/>
+          </p:cNvSpPr>
+          <p:nvPr>
+            <p:ph type="body" sz="quarter" idx="13"/>
+          </p:nvPr>
+        </p:nvSpPr>
+        <p:spPr>
+          <a:xfrm>
+            <a:off x="857739" y="1600201"/>
+            <a:ext cx="10160000" cy="2971799"/>
+          </a:xfrm>
+        </p:spPr>
+        <p:txBody>
+          <a:bodyPr>
+            <a:normAutofit/>
+          </a:bodyPr>
+          <a:lstStyle/>
+          <a:p>
+            <a:r>
+              <a:rPr lang="en-US" dirty="0"/>
+              <a:t>Definition of DevOps:</a:t>
+            </a:r>
+          </a:p>
+          <a:p>
+            <a:pPr lvl="1"/>
+            <a:r>
+              <a:rPr lang="en-US" dirty="0"/>
+              <a:t>“DevOps is a set of practices intended to reduce the time between committing a change to a system and the change being placed into normal production, while ensuring high quality”</a:t>
+            </a:r>
+          </a:p>
+          <a:p>
             <a:endParaRPr lang="en-US" dirty="0"/>
+          </a:p>
+          <a:p>
+            <a:r>
+              <a:rPr lang="en-US" dirty="0"/>
+              <a:t>Implications of this definition</a:t>
+            </a:r>
+          </a:p>
+          <a:p>
+            <a:pPr lvl="1"/>
+            <a:r>
+              <a:rPr lang="en-US" dirty="0"/>
+              <a:t>Practices and tools</a:t>
+            </a:r>
+          </a:p>
+          <a:p>
+            <a:pPr lvl="1"/>
+            <a:r>
+              <a:rPr lang="en-US" dirty="0"/>
+              <a:t>Do not restricted scope of DevOps to testing and development </a:t>
+            </a:r>
+          </a:p>
+          <a:p>
+            <a:endParaRPr lang="en-US" dirty="0"/>
+          </a:p>
+        </p:txBody>
+      </p:sp>
+      <p:sp>
+        <p:nvSpPr>
+          <p:cNvPr id="4" name="Text Placeholder 3"/>
+          <p:cNvSpPr>
+            <a:spLocks noGrp="1"/>
+          </p:cNvSpPr>
+          <p:nvPr>
+            <p:ph type="body" sz="quarter" idx="14"/>
+          </p:nvPr>
+        </p:nvSpPr>
+        <p:spPr/>
+        <p:txBody>
+          <a:bodyPr/>
+          <a:lstStyle/>
+          <a:p>
+            <a:r>
+              <a:rPr lang="en-US" dirty="0"/>
+              <a:t>Introduction Contd..</a:t>
+            </a:r>
+          </a:p>
+        </p:txBody>
+      </p:sp>
+    </p:spTree>
+    <p:extLst>
+      <p:ext uri="{BB962C8B-B14F-4D97-AF65-F5344CB8AC3E}">
+        <p14:creationId xmlns:p14="http://schemas.microsoft.com/office/powerpoint/2010/main" val="1008182945"/>
+      </p:ext>
+    </p:extLst>
+  </p:cSld>
+  <p:clrMapOvr>
+    <a:masterClrMapping/>
+  </p:clrMapOvr>
+</p:sld>
+</file>
+
+<file path=ppt/slides/slide3.xml><?xml version="1.0" encoding="utf-8"?>
+<p:sld xmlns:a="http://schemas.openxmlformats.org/drawingml/2006/main" xmlns:r="http://schemas.openxmlformats.org/officeDocument/2006/relationships" xmlns:p="http://schemas.openxmlformats.org/presentationml/2006/main">
+  <p:cSld>
+    <p:spTree>
+      <p:nvGrpSpPr>
+        <p:cNvPr id="1" name=""/>
+        <p:cNvGrpSpPr/>
+        <p:nvPr/>
+      </p:nvGrpSpPr>
+      <p:grpSpPr>
+        <a:xfrm>
+          <a:off x="0" y="0"/>
+          <a:ext cx="0" cy="0"/>
+          <a:chOff x="0" y="0"/>
+          <a:chExt cx="0" cy="0"/>
+        </a:xfrm>
+      </p:grpSpPr>
+      <p:sp>
+        <p:nvSpPr>
+          <p:cNvPr id="2" name="Title 1"/>
+          <p:cNvSpPr>
+            <a:spLocks noGrp="1"/>
+          </p:cNvSpPr>
+          <p:nvPr>
+            <p:ph type="title"/>
+          </p:nvPr>
+        </p:nvSpPr>
+        <p:spPr/>
+        <p:txBody>
+          <a:bodyPr/>
+          <a:lstStyle/>
+          <a:p>
+            <a:r>
+              <a:rPr lang="en-US" dirty="0"/>
+              <a:t>DevOps Basics </a:t>
+            </a:r>
+          </a:p>
+        </p:txBody>
+      </p:sp>
+      <p:sp>
+        <p:nvSpPr>
+          <p:cNvPr id="3" name="Text Placeholder 2"/>
+          <p:cNvSpPr>
+            <a:spLocks noGrp="1"/>
+          </p:cNvSpPr>
+          <p:nvPr>
+            <p:ph type="body" sz="quarter" idx="13"/>
+          </p:nvPr>
+        </p:nvSpPr>
+        <p:spPr/>
+        <p:txBody>
+          <a:bodyPr/>
+          <a:lstStyle/>
+          <a:p>
+            <a:r>
+              <a:rPr lang="en-US" dirty="0"/>
+              <a:t>Developer :- Writing Code</a:t>
+            </a:r>
+          </a:p>
+          <a:p>
+            <a:endParaRPr lang="en-US" dirty="0"/>
+          </a:p>
+          <a:p>
+            <a:r>
+              <a:rPr lang="en-US" dirty="0"/>
+              <a:t>Quality Assurance :- Testing </a:t>
+            </a:r>
+          </a:p>
+          <a:p>
+            <a:endParaRPr lang="en-US" dirty="0"/>
+          </a:p>
+          <a:p>
+            <a:r>
+              <a:rPr lang="en-US" dirty="0"/>
+              <a:t>Operations personnel :- Deploy </a:t>
+            </a:r>
+          </a:p>
+          <a:p>
+            <a:endParaRPr lang="en-US" dirty="0"/>
+          </a:p>
+        </p:txBody>
+      </p:sp>
+      <p:sp>
+        <p:nvSpPr>
+          <p:cNvPr id="4" name="Text Placeholder 3"/>
+          <p:cNvSpPr>
+            <a:spLocks noGrp="1"/>
+          </p:cNvSpPr>
+          <p:nvPr>
+            <p:ph type="body" sz="quarter" idx="14"/>
+          </p:nvPr>
+        </p:nvSpPr>
+        <p:spPr/>
+        <p:txBody>
+          <a:bodyPr/>
+          <a:lstStyle/>
+          <a:p>
+            <a:r>
+              <a:rPr lang="en-US" dirty="0"/>
+              <a:t>Need for DevOps </a:t>
+            </a:r>
+          </a:p>
+        </p:txBody>
+      </p:sp>
+      <p:graphicFrame>
+        <p:nvGraphicFramePr>
+          <p:cNvPr id="5" name="Content Placeholder 5"/>
+          <p:cNvGraphicFramePr>
+            <a:graphicFrameLocks/>
+          </p:cNvGraphicFramePr>
+          <p:nvPr>
+            <p:extLst>
+              <p:ext uri="{D42A27DB-BD31-4B8C-83A1-F6EECF244321}">
+                <p14:modId xmlns:p14="http://schemas.microsoft.com/office/powerpoint/2010/main" val="2592704613"/>
+              </p:ext>
+            </p:extLst>
+          </p:nvPr>
+        </p:nvGraphicFramePr>
+        <p:xfrm>
+          <a:off x="5181600" y="2819400"/>
+          <a:ext cx="5164541" cy="3738562"/>
+        </p:xfrm>
+        <a:graphic>
+          <a:graphicData uri="http://schemas.openxmlformats.org/drawingml/2006/diagram">
+            <dgm:relIds xmlns:dgm="http://schemas.openxmlformats.org/drawingml/2006/diagram" xmlns:r="http://schemas.openxmlformats.org/officeDocument/2006/relationships" r:dm="rId2" r:lo="rId3" r:qs="rId4" r:cs="rId5"/>
+          </a:graphicData>
+        </a:graphic>
+      </p:graphicFrame>
+    </p:spTree>
+    <p:extLst>
+      <p:ext uri="{BB962C8B-B14F-4D97-AF65-F5344CB8AC3E}">
+        <p14:creationId xmlns:p14="http://schemas.microsoft.com/office/powerpoint/2010/main" val="2275560999"/>
+      </p:ext>
+    </p:extLst>
+  </p:cSld>
+  <p:clrMapOvr>
+    <a:masterClrMapping/>
+  </p:clrMapOvr>
+</p:sld>
+</file>
+
+<file path=ppt/slides/slide4.xml><?xml version="1.0" encoding="utf-8"?>
+<p:sld xmlns:a="http://schemas.openxmlformats.org/drawingml/2006/main" xmlns:r="http://schemas.openxmlformats.org/officeDocument/2006/relationships" xmlns:p="http://schemas.openxmlformats.org/presentationml/2006/main">
+  <p:cSld>
+    <p:spTree>
+      <p:nvGrpSpPr>
+        <p:cNvPr id="1" name=""/>
+        <p:cNvGrpSpPr/>
+        <p:nvPr/>
+      </p:nvGrpSpPr>
+      <p:grpSpPr>
+        <a:xfrm>
+          <a:off x="0" y="0"/>
+          <a:ext cx="0" cy="0"/>
+          <a:chOff x="0" y="0"/>
+          <a:chExt cx="0" cy="0"/>
+        </a:xfrm>
+      </p:grpSpPr>
+      <p:sp>
+        <p:nvSpPr>
+          <p:cNvPr id="2" name="Title 1"/>
+          <p:cNvSpPr>
+            <a:spLocks noGrp="1"/>
+          </p:cNvSpPr>
+          <p:nvPr>
+            <p:ph type="title"/>
+          </p:nvPr>
+        </p:nvSpPr>
+        <p:spPr/>
+        <p:txBody>
+          <a:bodyPr/>
+          <a:lstStyle/>
+          <a:p>
+            <a:r>
+              <a:rPr lang="en-US" dirty="0"/>
+              <a:t>DevOps Basics</a:t>
+            </a:r>
+          </a:p>
+        </p:txBody>
+      </p:sp>
+      <p:sp>
+        <p:nvSpPr>
+          <p:cNvPr id="4" name="Text Placeholder 3"/>
+          <p:cNvSpPr>
+            <a:spLocks noGrp="1"/>
+          </p:cNvSpPr>
+          <p:nvPr>
+            <p:ph type="body" sz="quarter" idx="14"/>
+          </p:nvPr>
+        </p:nvSpPr>
+        <p:spPr/>
+        <p:txBody>
+          <a:bodyPr/>
+          <a:lstStyle/>
+          <a:p>
+            <a:r>
+              <a:rPr lang="en-US" dirty="0"/>
+              <a:t>Need for DevOps Contd..</a:t>
+            </a:r>
+          </a:p>
+        </p:txBody>
+      </p:sp>
+      <p:graphicFrame>
+        <p:nvGraphicFramePr>
+          <p:cNvPr id="9" name="Content Placeholder 5"/>
+          <p:cNvGraphicFramePr>
+            <a:graphicFrameLocks/>
+          </p:cNvGraphicFramePr>
+          <p:nvPr>
+            <p:extLst>
+              <p:ext uri="{D42A27DB-BD31-4B8C-83A1-F6EECF244321}">
+                <p14:modId xmlns:p14="http://schemas.microsoft.com/office/powerpoint/2010/main" val="4045946368"/>
+              </p:ext>
+            </p:extLst>
+          </p:nvPr>
+        </p:nvGraphicFramePr>
+        <p:xfrm>
+          <a:off x="8342572" y="1623218"/>
+          <a:ext cx="3282950" cy="4351338"/>
+        </p:xfrm>
+        <a:graphic>
+          <a:graphicData uri="http://schemas.openxmlformats.org/drawingml/2006/diagram">
+            <dgm:relIds xmlns:dgm="http://schemas.openxmlformats.org/drawingml/2006/diagram" xmlns:r="http://schemas.openxmlformats.org/officeDocument/2006/relationships" r:dm="rId2" r:lo="rId3" r:qs="rId4" r:cs="rId5"/>
+          </a:graphicData>
+        </a:graphic>
+      </p:graphicFrame>
+      <p:graphicFrame>
+        <p:nvGraphicFramePr>
+          <p:cNvPr id="10" name="Content Placeholder 4"/>
+          <p:cNvGraphicFramePr>
+            <a:graphicFrameLocks/>
+          </p:cNvGraphicFramePr>
+          <p:nvPr>
+            <p:extLst>
+              <p:ext uri="{D42A27DB-BD31-4B8C-83A1-F6EECF244321}">
+                <p14:modId xmlns:p14="http://schemas.microsoft.com/office/powerpoint/2010/main" val="4233279266"/>
+              </p:ext>
+            </p:extLst>
+          </p:nvPr>
+        </p:nvGraphicFramePr>
+        <p:xfrm>
+          <a:off x="122829" y="1555750"/>
+          <a:ext cx="8194343" cy="4486275"/>
+        </p:xfrm>
+        <a:graphic>
+          <a:graphicData uri="http://schemas.openxmlformats.org/drawingml/2006/diagram">
+            <dgm:relIds xmlns:dgm="http://schemas.openxmlformats.org/drawingml/2006/diagram" xmlns:r="http://schemas.openxmlformats.org/officeDocument/2006/relationships" r:dm="rId7" r:lo="rId8" r:qs="rId9" r:cs="rId10"/>
+          </a:graphicData>
+        </a:graphic>
+      </p:graphicFrame>
+    </p:spTree>
+    <p:extLst>
+      <p:ext uri="{BB962C8B-B14F-4D97-AF65-F5344CB8AC3E}">
+        <p14:creationId xmlns:p14="http://schemas.microsoft.com/office/powerpoint/2010/main" val="2387696097"/>
+      </p:ext>
+    </p:extLst>
+  </p:cSld>
+  <p:clrMapOvr>
+    <a:masterClrMapping/>
+  </p:clrMapOvr>
+</p:sld>
+</file>
+
+<file path=ppt/slides/slide5.xml><?xml version="1.0" encoding="utf-8"?>
+<p:sld xmlns:a="http://schemas.openxmlformats.org/drawingml/2006/main" xmlns:r="http://schemas.openxmlformats.org/officeDocument/2006/relationships" xmlns:p="http://schemas.openxmlformats.org/presentationml/2006/main">
+  <p:cSld>
+    <p:spTree>
+      <p:nvGrpSpPr>
+        <p:cNvPr id="1" name=""/>
+        <p:cNvGrpSpPr/>
+        <p:nvPr/>
+      </p:nvGrpSpPr>
+      <p:grpSpPr>
+        <a:xfrm>
+          <a:off x="0" y="0"/>
+          <a:ext cx="0" cy="0"/>
+          <a:chOff x="0" y="0"/>
+          <a:chExt cx="0" cy="0"/>
+        </a:xfrm>
+      </p:grpSpPr>
+      <p:sp>
+        <p:nvSpPr>
+          <p:cNvPr id="2" name="Title 1"/>
+          <p:cNvSpPr>
+            <a:spLocks noGrp="1"/>
+          </p:cNvSpPr>
+          <p:nvPr>
+            <p:ph type="title"/>
+          </p:nvPr>
+        </p:nvSpPr>
+        <p:spPr/>
+        <p:txBody>
+          <a:bodyPr/>
+          <a:lstStyle/>
+          <a:p>
+            <a:r>
+              <a:rPr lang="en-US" dirty="0"/>
+              <a:t>DevOps Basics</a:t>
+            </a:r>
+          </a:p>
+        </p:txBody>
+      </p:sp>
+      <p:sp>
+        <p:nvSpPr>
+          <p:cNvPr id="4" name="Text Placeholder 3"/>
+          <p:cNvSpPr>
+            <a:spLocks noGrp="1"/>
+          </p:cNvSpPr>
+          <p:nvPr>
+            <p:ph type="body" sz="quarter" idx="14"/>
+          </p:nvPr>
+        </p:nvSpPr>
+        <p:spPr/>
+        <p:txBody>
+          <a:bodyPr/>
+          <a:lstStyle/>
+          <a:p>
+            <a:r>
+              <a:rPr lang="en-US" dirty="0"/>
+              <a:t>Need for DevOps Contd..</a:t>
+            </a:r>
+          </a:p>
+        </p:txBody>
+      </p:sp>
+      <p:graphicFrame>
+        <p:nvGraphicFramePr>
+          <p:cNvPr id="5" name="Content Placeholder 5"/>
+          <p:cNvGraphicFramePr>
+            <a:graphicFrameLocks/>
+          </p:cNvGraphicFramePr>
+          <p:nvPr>
+            <p:extLst>
+              <p:ext uri="{D42A27DB-BD31-4B8C-83A1-F6EECF244321}">
+                <p14:modId xmlns:p14="http://schemas.microsoft.com/office/powerpoint/2010/main" val="2659680095"/>
+              </p:ext>
+            </p:extLst>
+          </p:nvPr>
+        </p:nvGraphicFramePr>
+        <p:xfrm>
+          <a:off x="6461078" y="1690688"/>
+          <a:ext cx="5181600" cy="4351338"/>
+        </p:xfrm>
+        <a:graphic>
+          <a:graphicData uri="http://schemas.openxmlformats.org/drawingml/2006/diagram">
+            <dgm:relIds xmlns:dgm="http://schemas.openxmlformats.org/drawingml/2006/diagram" xmlns:r="http://schemas.openxmlformats.org/officeDocument/2006/relationships" r:dm="rId2" r:lo="rId3" r:qs="rId4" r:cs="rId5"/>
+          </a:graphicData>
+        </a:graphic>
+      </p:graphicFrame>
+      <p:graphicFrame>
+        <p:nvGraphicFramePr>
+          <p:cNvPr id="6" name="Content Placeholder 6"/>
+          <p:cNvGraphicFramePr>
+            <a:graphicFrameLocks/>
+          </p:cNvGraphicFramePr>
+          <p:nvPr>
+            <p:extLst>
+              <p:ext uri="{D42A27DB-BD31-4B8C-83A1-F6EECF244321}">
+                <p14:modId xmlns:p14="http://schemas.microsoft.com/office/powerpoint/2010/main" val="162877414"/>
+              </p:ext>
+            </p:extLst>
+          </p:nvPr>
+        </p:nvGraphicFramePr>
+        <p:xfrm>
+          <a:off x="914400" y="1690688"/>
+          <a:ext cx="5257800" cy="4351338"/>
+        </p:xfrm>
+        <a:graphic>
+          <a:graphicData uri="http://schemas.openxmlformats.org/drawingml/2006/diagram">
+            <dgm:relIds xmlns:dgm="http://schemas.openxmlformats.org/drawingml/2006/diagram" xmlns:r="http://schemas.openxmlformats.org/officeDocument/2006/relationships" r:dm="rId7" r:lo="rId8" r:qs="rId9" r:cs="rId10"/>
+          </a:graphicData>
+        </a:graphic>
+      </p:graphicFrame>
+    </p:spTree>
+    <p:extLst>
+      <p:ext uri="{BB962C8B-B14F-4D97-AF65-F5344CB8AC3E}">
+        <p14:creationId xmlns:p14="http://schemas.microsoft.com/office/powerpoint/2010/main" val="1461455547"/>
+      </p:ext>
+    </p:extLst>
+  </p:cSld>
+  <p:clrMapOvr>
+    <a:masterClrMapping/>
+  </p:clrMapOvr>
+</p:sld>
+</file>
+
+<file path=ppt/slides/slide6.xml><?xml version="1.0" encoding="utf-8"?>
+<p:sld xmlns:a="http://schemas.openxmlformats.org/drawingml/2006/main" xmlns:r="http://schemas.openxmlformats.org/officeDocument/2006/relationships" xmlns:p="http://schemas.openxmlformats.org/presentationml/2006/main">
+  <p:cSld>
+    <p:spTree>
+      <p:nvGrpSpPr>
+        <p:cNvPr id="1" name=""/>
+        <p:cNvGrpSpPr/>
+        <p:nvPr/>
+      </p:nvGrpSpPr>
+      <p:grpSpPr>
+        <a:xfrm>
+          <a:off x="0" y="0"/>
+          <a:ext cx="0" cy="0"/>
+          <a:chOff x="0" y="0"/>
+          <a:chExt cx="0" cy="0"/>
+        </a:xfrm>
+      </p:grpSpPr>
+      <p:sp>
+        <p:nvSpPr>
+          <p:cNvPr id="2" name="Title 1"/>
+          <p:cNvSpPr>
+            <a:spLocks noGrp="1"/>
+          </p:cNvSpPr>
+          <p:nvPr>
+            <p:ph type="title"/>
+          </p:nvPr>
+        </p:nvSpPr>
+        <p:spPr/>
+        <p:txBody>
+          <a:bodyPr/>
+          <a:lstStyle/>
+          <a:p>
+            <a:r>
+              <a:rPr lang="en-US" dirty="0"/>
+              <a:t>DevOps Basics</a:t>
+            </a:r>
+          </a:p>
+        </p:txBody>
+      </p:sp>
+      <p:sp>
+        <p:nvSpPr>
+          <p:cNvPr id="4" name="Text Placeholder 3"/>
+          <p:cNvSpPr>
+            <a:spLocks noGrp="1"/>
+          </p:cNvSpPr>
+          <p:nvPr>
+            <p:ph type="body" sz="quarter" idx="14"/>
+          </p:nvPr>
+        </p:nvSpPr>
+        <p:spPr/>
+        <p:txBody>
+          <a:bodyPr/>
+          <a:lstStyle/>
+          <a:p>
+            <a:r>
+              <a:rPr lang="en-US" dirty="0"/>
+              <a:t>Need for DevOps Contd..</a:t>
+            </a:r>
+          </a:p>
+        </p:txBody>
+      </p:sp>
+      <p:pic>
+        <p:nvPicPr>
+          <p:cNvPr id="3" name="Picture 2"/>
+          <p:cNvPicPr>
+            <a:picLocks noChangeAspect="1"/>
+          </p:cNvPicPr>
+          <p:nvPr/>
+        </p:nvPicPr>
+        <p:blipFill>
+          <a:blip r:embed="rId2"/>
+          <a:stretch>
+            <a:fillRect/>
+          </a:stretch>
+        </p:blipFill>
+        <p:spPr>
+          <a:xfrm>
+            <a:off x="2057400" y="1756356"/>
+            <a:ext cx="7696200" cy="4071937"/>
+          </a:xfrm>
+          <a:prstGeom prst="rect">
+            <a:avLst/>
+          </a:prstGeom>
+        </p:spPr>
+      </p:pic>
+      <p:sp>
+        <p:nvSpPr>
+          <p:cNvPr id="7" name="TextBox 6"/>
+          <p:cNvSpPr txBox="1"/>
+          <p:nvPr/>
+        </p:nvSpPr>
+        <p:spPr>
+          <a:xfrm>
+            <a:off x="8077200" y="5877084"/>
+            <a:ext cx="2819400" cy="338554"/>
+          </a:xfrm>
+          <a:prstGeom prst="rect">
+            <a:avLst/>
+          </a:prstGeom>
+          <a:noFill/>
+        </p:spPr>
+        <p:txBody>
+          <a:bodyPr wrap="square" rtlCol="0">
+            <a:spAutoFit/>
+          </a:bodyPr>
+          <a:lstStyle/>
+          <a:p>
+            <a:r>
+              <a:rPr lang="en-US" sz="1600" dirty="0">
+                <a:latin typeface="Helvetica" panose="020B0604020202020204" pitchFamily="34" charset="0"/>
+                <a:cs typeface="Helvetica" panose="020B0604020202020204" pitchFamily="34" charset="0"/>
+              </a:rPr>
+              <a:t>https://in.pinterest.com/</a:t>
+            </a:r>
+          </a:p>
+        </p:txBody>
+      </p:sp>
+    </p:spTree>
+    <p:extLst>
+      <p:ext uri="{BB962C8B-B14F-4D97-AF65-F5344CB8AC3E}">
+        <p14:creationId xmlns:p14="http://schemas.microsoft.com/office/powerpoint/2010/main" val="3394443243"/>
+      </p:ext>
+    </p:extLst>
+  </p:cSld>
+  <p:clrMapOvr>
+    <a:masterClrMapping/>
+  </p:clrMapOvr>
+</p:sld>
+</file>
+
+<file path=ppt/slides/slide7.xml><?xml version="1.0" encoding="utf-8"?>
+<p:sld xmlns:a="http://schemas.openxmlformats.org/drawingml/2006/main" xmlns:r="http://schemas.openxmlformats.org/officeDocument/2006/relationships" xmlns:p="http://schemas.openxmlformats.org/presentationml/2006/main">
+  <p:cSld>
+    <p:spTree>
+      <p:nvGrpSpPr>
+        <p:cNvPr id="1" name=""/>
+        <p:cNvGrpSpPr/>
+        <p:nvPr/>
+      </p:nvGrpSpPr>
+      <p:grpSpPr>
+        <a:xfrm>
+          <a:off x="0" y="0"/>
+          <a:ext cx="0" cy="0"/>
+          <a:chOff x="0" y="0"/>
+          <a:chExt cx="0" cy="0"/>
+        </a:xfrm>
+      </p:grpSpPr>
+      <p:sp>
+        <p:nvSpPr>
+          <p:cNvPr id="2" name="Title 1"/>
+          <p:cNvSpPr>
+            <a:spLocks noGrp="1"/>
+          </p:cNvSpPr>
+          <p:nvPr>
+            <p:ph type="title"/>
+          </p:nvPr>
+        </p:nvSpPr>
+        <p:spPr/>
+        <p:txBody>
+          <a:bodyPr/>
+          <a:lstStyle/>
+          <a:p>
+            <a:r>
+              <a:rPr lang="en-US" dirty="0"/>
+              <a:t>DevOps Basics</a:t>
+            </a:r>
+          </a:p>
+        </p:txBody>
+      </p:sp>
+      <p:sp>
+        <p:nvSpPr>
+          <p:cNvPr id="3" name="Text Placeholder 2"/>
+          <p:cNvSpPr>
+            <a:spLocks noGrp="1"/>
+          </p:cNvSpPr>
+          <p:nvPr>
+            <p:ph type="body" sz="quarter" idx="13"/>
+          </p:nvPr>
+        </p:nvSpPr>
+        <p:spPr>
+          <a:xfrm>
+            <a:off x="857739" y="1600201"/>
+            <a:ext cx="10160000" cy="3962399"/>
+          </a:xfrm>
+        </p:spPr>
+        <p:txBody>
+          <a:bodyPr>
+            <a:normAutofit fontScale="92500" lnSpcReduction="10000"/>
+          </a:bodyPr>
+          <a:lstStyle/>
+          <a:p>
+            <a:r>
+              <a:rPr lang="en-US" dirty="0"/>
+              <a:t>Waterfall Model</a:t>
+            </a:r>
+          </a:p>
+          <a:p>
+            <a:r>
+              <a:rPr lang="en-US" dirty="0"/>
+              <a:t>Dominated Project Management Until 2001</a:t>
+            </a:r>
+          </a:p>
+          <a:p>
+            <a:endParaRPr lang="en-US" dirty="0"/>
+          </a:p>
+          <a:p>
+            <a:r>
+              <a:rPr lang="en-US" dirty="0"/>
+              <a:t>Still in Use :</a:t>
+            </a:r>
+          </a:p>
+          <a:p>
+            <a:pPr lvl="1"/>
+            <a:r>
+              <a:rPr lang="en-US" dirty="0"/>
+              <a:t>Disciplined Approach</a:t>
+            </a:r>
+          </a:p>
+          <a:p>
+            <a:pPr lvl="1"/>
+            <a:r>
+              <a:rPr lang="en-US" dirty="0"/>
+              <a:t>Thorough Scoping</a:t>
+            </a:r>
+          </a:p>
+          <a:p>
+            <a:pPr lvl="1"/>
+            <a:r>
+              <a:rPr lang="en-US" dirty="0"/>
+              <a:t>Clear Stages</a:t>
+            </a:r>
+          </a:p>
+          <a:p>
+            <a:pPr lvl="1"/>
+            <a:r>
+              <a:rPr lang="en-US" dirty="0"/>
+              <a:t>Concrete Deadlines</a:t>
+            </a:r>
+          </a:p>
+          <a:p>
+            <a:endParaRPr lang="en-US" dirty="0"/>
+          </a:p>
+          <a:p>
+            <a:r>
+              <a:rPr lang="en-US" dirty="0"/>
+              <a:t>Disadvantages:</a:t>
+            </a:r>
+          </a:p>
+          <a:p>
+            <a:pPr lvl="1"/>
+            <a:r>
+              <a:rPr lang="en-US" dirty="0"/>
+              <a:t>Sequential </a:t>
+            </a:r>
+          </a:p>
+          <a:p>
+            <a:pPr lvl="1"/>
+            <a:r>
+              <a:rPr lang="en-US" dirty="0"/>
+              <a:t>Inflexible</a:t>
+            </a:r>
+          </a:p>
+          <a:p>
+            <a:pPr lvl="1"/>
+            <a:r>
+              <a:rPr lang="en-US" dirty="0"/>
+              <a:t>Assumptions</a:t>
+            </a:r>
+          </a:p>
+        </p:txBody>
+      </p:sp>
+      <p:sp>
+        <p:nvSpPr>
+          <p:cNvPr id="4" name="Text Placeholder 3"/>
+          <p:cNvSpPr>
+            <a:spLocks noGrp="1"/>
+          </p:cNvSpPr>
+          <p:nvPr>
+            <p:ph type="body" sz="quarter" idx="14"/>
+          </p:nvPr>
+        </p:nvSpPr>
+        <p:spPr/>
+        <p:txBody>
+          <a:bodyPr/>
+          <a:lstStyle/>
+          <a:p>
+            <a:r>
+              <a:rPr lang="en-US" dirty="0"/>
+              <a:t>Need for DevOps Contd..</a:t>
+            </a:r>
+          </a:p>
+        </p:txBody>
+      </p:sp>
+      <p:sp>
+        <p:nvSpPr>
+          <p:cNvPr id="5" name="TextBox 4"/>
+          <p:cNvSpPr txBox="1"/>
+          <p:nvPr/>
+        </p:nvSpPr>
+        <p:spPr>
+          <a:xfrm>
+            <a:off x="3962400" y="5105400"/>
+            <a:ext cx="4876800" cy="369332"/>
+          </a:xfrm>
+          <a:prstGeom prst="rect">
+            <a:avLst/>
+          </a:prstGeom>
+          <a:noFill/>
+        </p:spPr>
+        <p:txBody>
+          <a:bodyPr wrap="square" rtlCol="0">
+            <a:spAutoFit/>
+          </a:bodyPr>
+          <a:lstStyle/>
+          <a:p>
+            <a:r>
+              <a:rPr lang="en-US" b="1" dirty="0">
+                <a:solidFill>
+                  <a:srgbClr val="FF0000"/>
+                </a:solidFill>
+                <a:latin typeface="Helvetica" panose="020B0604020202020204" pitchFamily="34" charset="0"/>
+                <a:cs typeface="Helvetica" panose="020B0604020202020204" pitchFamily="34" charset="0"/>
+              </a:rPr>
+              <a:t>We are loosing Time to market </a:t>
+            </a:r>
+          </a:p>
+        </p:txBody>
+      </p:sp>
+    </p:spTree>
+    <p:extLst>
+      <p:ext uri="{BB962C8B-B14F-4D97-AF65-F5344CB8AC3E}">
+        <p14:creationId xmlns:p14="http://schemas.microsoft.com/office/powerpoint/2010/main" val="882684043"/>
+      </p:ext>
+    </p:extLst>
+  </p:cSld>
+  <p:clrMapOvr>
+    <a:masterClrMapping/>
+  </p:clrMapOvr>
+</p:sld>
+</file>
+
+<file path=ppt/slides/slide8.xml><?xml version="1.0" encoding="utf-8"?>
+<p:sld xmlns:a="http://schemas.openxmlformats.org/drawingml/2006/main" xmlns:r="http://schemas.openxmlformats.org/officeDocument/2006/relationships" xmlns:p="http://schemas.openxmlformats.org/presentationml/2006/main">
+  <p:cSld>
+    <p:spTree>
+      <p:nvGrpSpPr>
+        <p:cNvPr id="1" name=""/>
+        <p:cNvGrpSpPr/>
+        <p:nvPr/>
+      </p:nvGrpSpPr>
+      <p:grpSpPr>
+        <a:xfrm>
+          <a:off x="0" y="0"/>
+          <a:ext cx="0" cy="0"/>
+          <a:chOff x="0" y="0"/>
+          <a:chExt cx="0" cy="0"/>
+        </a:xfrm>
+      </p:grpSpPr>
+      <p:sp>
+        <p:nvSpPr>
+          <p:cNvPr id="2" name="Title 1"/>
+          <p:cNvSpPr>
+            <a:spLocks noGrp="1"/>
+          </p:cNvSpPr>
+          <p:nvPr>
+            <p:ph type="title"/>
+          </p:nvPr>
+        </p:nvSpPr>
+        <p:spPr/>
+        <p:txBody>
+          <a:bodyPr/>
+          <a:lstStyle/>
+          <a:p>
+            <a:r>
+              <a:rPr lang="en-US" dirty="0"/>
+              <a:t>DevOps Basics</a:t>
+            </a:r>
           </a:p>
         </p:txBody>
       </p:sp>
@@ -21505,7 +21302,7 @@
 </p:sld>
 </file>
 
-<file path=ppt/slides/slide11.xml><?xml version="1.0" encoding="utf-8"?>
+<file path=ppt/slides/slide9.xml><?xml version="1.0" encoding="utf-8"?>
 <p:sld xmlns:a="http://schemas.openxmlformats.org/drawingml/2006/main" xmlns:r="http://schemas.openxmlformats.org/officeDocument/2006/relationships" xmlns:p="http://schemas.openxmlformats.org/presentationml/2006/main">
   <p:cSld>
     <p:spTree>
@@ -21538,10 +21335,9 @@
           <a:lstStyle/>
           <a:p>
             <a:r>
-              <a:rPr lang="en-US" dirty="0" smtClean="0"/>
+              <a:rPr lang="en-US" dirty="0"/>
               <a:t>DevOps Basics</a:t>
             </a:r>
-            <a:endParaRPr lang="en-US" dirty="0"/>
           </a:p>
         </p:txBody>
       </p:sp>
@@ -21657,1321 +21453,6 @@
     <p:extLst>
       <p:ext uri="{BB962C8B-B14F-4D97-AF65-F5344CB8AC3E}">
         <p14:creationId xmlns:p14="http://schemas.microsoft.com/office/powerpoint/2010/main" val="954071074"/>
-      </p:ext>
-    </p:extLst>
-  </p:cSld>
-  <p:clrMapOvr>
-    <a:masterClrMapping/>
-  </p:clrMapOvr>
-</p:sld>
-</file>
-
-<file path=ppt/slides/slide12.xml><?xml version="1.0" encoding="utf-8"?>
-<p:sld xmlns:a="http://schemas.openxmlformats.org/drawingml/2006/main" xmlns:r="http://schemas.openxmlformats.org/officeDocument/2006/relationships" xmlns:p="http://schemas.openxmlformats.org/presentationml/2006/main">
-  <p:cSld>
-    <p:spTree>
-      <p:nvGrpSpPr>
-        <p:cNvPr id="1" name=""/>
-        <p:cNvGrpSpPr/>
-        <p:nvPr/>
-      </p:nvGrpSpPr>
-      <p:grpSpPr>
-        <a:xfrm>
-          <a:off x="0" y="0"/>
-          <a:ext cx="0" cy="0"/>
-          <a:chOff x="0" y="0"/>
-          <a:chExt cx="0" cy="0"/>
-        </a:xfrm>
-      </p:grpSpPr>
-      <p:sp>
-        <p:nvSpPr>
-          <p:cNvPr id="2" name="Title 1"/>
-          <p:cNvSpPr>
-            <a:spLocks noGrp="1"/>
-          </p:cNvSpPr>
-          <p:nvPr>
-            <p:ph type="title"/>
-          </p:nvPr>
-        </p:nvSpPr>
-        <p:spPr>
-          <a:xfrm>
-            <a:off x="831850" y="3657600"/>
-            <a:ext cx="10515600" cy="904875"/>
-          </a:xfrm>
-        </p:spPr>
-        <p:txBody>
-          <a:bodyPr/>
-          <a:lstStyle/>
-          <a:p>
-            <a:r>
-              <a:rPr lang="en-US" dirty="0"/>
-              <a:t>Thank You!</a:t>
-            </a:r>
-          </a:p>
-        </p:txBody>
-      </p:sp>
-      <p:sp>
-        <p:nvSpPr>
-          <p:cNvPr id="3" name="Text Placeholder 2"/>
-          <p:cNvSpPr>
-            <a:spLocks noGrp="1"/>
-          </p:cNvSpPr>
-          <p:nvPr>
-            <p:ph type="body" idx="1"/>
-          </p:nvPr>
-        </p:nvSpPr>
-        <p:spPr>
-          <a:xfrm>
-            <a:off x="831850" y="5205413"/>
-            <a:ext cx="10515600" cy="1500187"/>
-          </a:xfrm>
-        </p:spPr>
-        <p:txBody>
-          <a:bodyPr/>
-          <a:lstStyle/>
-          <a:p>
-            <a:r>
-              <a:rPr lang="en-US" dirty="0" smtClean="0"/>
-              <a:t>In our next session:</a:t>
-            </a:r>
-            <a:endParaRPr lang="en-US" dirty="0"/>
-          </a:p>
-        </p:txBody>
-      </p:sp>
-    </p:spTree>
-    <p:extLst>
-      <p:ext uri="{BB962C8B-B14F-4D97-AF65-F5344CB8AC3E}">
-        <p14:creationId xmlns:p14="http://schemas.microsoft.com/office/powerpoint/2010/main" val="4195798294"/>
-      </p:ext>
-    </p:extLst>
-  </p:cSld>
-  <p:clrMapOvr>
-    <a:masterClrMapping/>
-  </p:clrMapOvr>
-  <p:timing>
-    <p:tnLst>
-      <p:par>
-        <p:cTn id="1" dur="indefinite" restart="never" nodeType="tmRoot"/>
-      </p:par>
-    </p:tnLst>
-  </p:timing>
-</p:sld>
-</file>
-
-<file path=ppt/slides/slide2.xml><?xml version="1.0" encoding="utf-8"?>
-<p:sld xmlns:a="http://schemas.openxmlformats.org/drawingml/2006/main" xmlns:r="http://schemas.openxmlformats.org/officeDocument/2006/relationships" xmlns:p="http://schemas.openxmlformats.org/presentationml/2006/main">
-  <p:cSld>
-    <p:spTree>
-      <p:nvGrpSpPr>
-        <p:cNvPr id="1" name=""/>
-        <p:cNvGrpSpPr/>
-        <p:nvPr/>
-      </p:nvGrpSpPr>
-      <p:grpSpPr>
-        <a:xfrm>
-          <a:off x="0" y="0"/>
-          <a:ext cx="0" cy="0"/>
-          <a:chOff x="0" y="0"/>
-          <a:chExt cx="0" cy="0"/>
-        </a:xfrm>
-      </p:grpSpPr>
-      <p:sp>
-        <p:nvSpPr>
-          <p:cNvPr id="3" name="Text Placeholder 2"/>
-          <p:cNvSpPr>
-            <a:spLocks noGrp="1"/>
-          </p:cNvSpPr>
-          <p:nvPr>
-            <p:ph type="body" sz="quarter" idx="13"/>
-          </p:nvPr>
-        </p:nvSpPr>
-        <p:spPr/>
-        <p:txBody>
-          <a:bodyPr/>
-          <a:lstStyle/>
-          <a:p>
-            <a:r>
-              <a:rPr lang="en-US" dirty="0"/>
-              <a:t>Introduction to </a:t>
-            </a:r>
-            <a:r>
-              <a:rPr lang="en-US" dirty="0" smtClean="0"/>
-              <a:t>DevOps</a:t>
-            </a:r>
-          </a:p>
-          <a:p>
-            <a:r>
-              <a:rPr lang="en-US" dirty="0"/>
-              <a:t>Need for </a:t>
-            </a:r>
-            <a:r>
-              <a:rPr lang="en-US" dirty="0" smtClean="0"/>
-              <a:t>DevOps </a:t>
-            </a:r>
-          </a:p>
-          <a:p>
-            <a:r>
-              <a:rPr lang="en-US" dirty="0" smtClean="0"/>
-              <a:t>Why DevOps</a:t>
-            </a:r>
-            <a:endParaRPr lang="en-US" dirty="0"/>
-          </a:p>
-        </p:txBody>
-      </p:sp>
-      <p:sp>
-        <p:nvSpPr>
-          <p:cNvPr id="4" name="Text Placeholder 3"/>
-          <p:cNvSpPr>
-            <a:spLocks noGrp="1"/>
-          </p:cNvSpPr>
-          <p:nvPr>
-            <p:ph type="body" sz="quarter" idx="14"/>
-          </p:nvPr>
-        </p:nvSpPr>
-        <p:spPr>
-          <a:xfrm>
-            <a:off x="329247" y="1143001"/>
-            <a:ext cx="11196956" cy="395287"/>
-          </a:xfrm>
-        </p:spPr>
-        <p:txBody>
-          <a:bodyPr/>
-          <a:lstStyle/>
-          <a:p>
-            <a:r>
-              <a:rPr lang="en-IN" dirty="0" smtClean="0"/>
-              <a:t>DevOps Basics</a:t>
-            </a:r>
-            <a:endParaRPr lang="en-US" dirty="0"/>
-          </a:p>
-        </p:txBody>
-      </p:sp>
-      <p:sp>
-        <p:nvSpPr>
-          <p:cNvPr id="5" name="Title 4"/>
-          <p:cNvSpPr>
-            <a:spLocks noGrp="1"/>
-          </p:cNvSpPr>
-          <p:nvPr>
-            <p:ph type="title"/>
-          </p:nvPr>
-        </p:nvSpPr>
-        <p:spPr/>
-        <p:txBody>
-          <a:bodyPr/>
-          <a:lstStyle/>
-          <a:p>
-            <a:r>
-              <a:rPr lang="en-US" dirty="0" smtClean="0"/>
-              <a:t>Agenda</a:t>
-            </a:r>
-            <a:endParaRPr lang="en-US" dirty="0"/>
-          </a:p>
-        </p:txBody>
-      </p:sp>
-    </p:spTree>
-    <p:extLst>
-      <p:ext uri="{BB962C8B-B14F-4D97-AF65-F5344CB8AC3E}">
-        <p14:creationId xmlns:p14="http://schemas.microsoft.com/office/powerpoint/2010/main" val="1092033935"/>
-      </p:ext>
-    </p:extLst>
-  </p:cSld>
-  <p:clrMapOvr>
-    <a:masterClrMapping/>
-  </p:clrMapOvr>
-  <p:timing>
-    <p:tnLst>
-      <p:par>
-        <p:cTn id="1" dur="indefinite" restart="never" nodeType="tmRoot"/>
-      </p:par>
-    </p:tnLst>
-  </p:timing>
-</p:sld>
-</file>
-
-<file path=ppt/slides/slide3.xml><?xml version="1.0" encoding="utf-8"?>
-<p:sld xmlns:a="http://schemas.openxmlformats.org/drawingml/2006/main" xmlns:r="http://schemas.openxmlformats.org/officeDocument/2006/relationships" xmlns:p="http://schemas.openxmlformats.org/presentationml/2006/main">
-  <p:cSld>
-    <p:spTree>
-      <p:nvGrpSpPr>
-        <p:cNvPr id="1" name=""/>
-        <p:cNvGrpSpPr/>
-        <p:nvPr/>
-      </p:nvGrpSpPr>
-      <p:grpSpPr>
-        <a:xfrm>
-          <a:off x="0" y="0"/>
-          <a:ext cx="0" cy="0"/>
-          <a:chOff x="0" y="0"/>
-          <a:chExt cx="0" cy="0"/>
-        </a:xfrm>
-      </p:grpSpPr>
-      <p:sp>
-        <p:nvSpPr>
-          <p:cNvPr id="2" name="Title 1"/>
-          <p:cNvSpPr>
-            <a:spLocks noGrp="1"/>
-          </p:cNvSpPr>
-          <p:nvPr>
-            <p:ph type="title"/>
-          </p:nvPr>
-        </p:nvSpPr>
-        <p:spPr/>
-        <p:txBody>
-          <a:bodyPr/>
-          <a:lstStyle/>
-          <a:p>
-            <a:r>
-              <a:rPr lang="en-US" dirty="0" smtClean="0"/>
-              <a:t>DevOps Basics</a:t>
-            </a:r>
-            <a:endParaRPr lang="en-US" dirty="0"/>
-          </a:p>
-        </p:txBody>
-      </p:sp>
-      <p:sp>
-        <p:nvSpPr>
-          <p:cNvPr id="3" name="Text Placeholder 2"/>
-          <p:cNvSpPr>
-            <a:spLocks noGrp="1"/>
-          </p:cNvSpPr>
-          <p:nvPr>
-            <p:ph type="body" sz="quarter" idx="13"/>
-          </p:nvPr>
-        </p:nvSpPr>
-        <p:spPr>
-          <a:xfrm>
-            <a:off x="857739" y="1600201"/>
-            <a:ext cx="10160000" cy="2971799"/>
-          </a:xfrm>
-        </p:spPr>
-        <p:txBody>
-          <a:bodyPr>
-            <a:normAutofit/>
-          </a:bodyPr>
-          <a:lstStyle/>
-          <a:p>
-            <a:r>
-              <a:rPr lang="en-US" dirty="0"/>
-              <a:t>A clipped compound of Development and Operations</a:t>
-            </a:r>
-          </a:p>
-          <a:p>
-            <a:r>
-              <a:rPr lang="en-US" dirty="0"/>
-              <a:t>Buzzword</a:t>
-            </a:r>
-          </a:p>
-          <a:p>
-            <a:r>
-              <a:rPr lang="en-US" dirty="0"/>
-              <a:t>Innovation for automation (pillar of DevOps)</a:t>
-            </a:r>
-          </a:p>
-          <a:p>
-            <a:r>
-              <a:rPr lang="en-US" dirty="0"/>
-              <a:t>DevOps is an approach based on lean and agile principles</a:t>
-            </a:r>
-          </a:p>
-          <a:p>
-            <a:r>
-              <a:rPr lang="en-US" dirty="0" smtClean="0"/>
-              <a:t>There are more </a:t>
-            </a:r>
-            <a:r>
-              <a:rPr lang="en-US" dirty="0"/>
-              <a:t>tangential DevOps Initiative</a:t>
-            </a:r>
-          </a:p>
-          <a:p>
-            <a:pPr lvl="1"/>
-            <a:r>
-              <a:rPr lang="en-US" dirty="0" err="1"/>
-              <a:t>WinOps</a:t>
-            </a:r>
-            <a:endParaRPr lang="en-US" dirty="0"/>
-          </a:p>
-          <a:p>
-            <a:pPr lvl="1"/>
-            <a:r>
-              <a:rPr lang="en-US" dirty="0" err="1"/>
-              <a:t>DevSecOps</a:t>
-            </a:r>
-            <a:endParaRPr lang="en-US" dirty="0"/>
-          </a:p>
-          <a:p>
-            <a:pPr lvl="1"/>
-            <a:r>
-              <a:rPr lang="en-US" dirty="0" err="1"/>
-              <a:t>BizDevOps</a:t>
-            </a:r>
-            <a:endParaRPr lang="en-US" dirty="0"/>
-          </a:p>
-          <a:p>
-            <a:endParaRPr lang="en-US" dirty="0"/>
-          </a:p>
-        </p:txBody>
-      </p:sp>
-      <p:sp>
-        <p:nvSpPr>
-          <p:cNvPr id="4" name="Text Placeholder 3"/>
-          <p:cNvSpPr>
-            <a:spLocks noGrp="1"/>
-          </p:cNvSpPr>
-          <p:nvPr>
-            <p:ph type="body" sz="quarter" idx="14"/>
-          </p:nvPr>
-        </p:nvSpPr>
-        <p:spPr/>
-        <p:txBody>
-          <a:bodyPr/>
-          <a:lstStyle/>
-          <a:p>
-            <a:r>
-              <a:rPr lang="en-US" dirty="0" smtClean="0"/>
-              <a:t>Introduction</a:t>
-            </a:r>
-            <a:endParaRPr lang="en-US" dirty="0"/>
-          </a:p>
-        </p:txBody>
-      </p:sp>
-    </p:spTree>
-    <p:extLst>
-      <p:ext uri="{BB962C8B-B14F-4D97-AF65-F5344CB8AC3E}">
-        <p14:creationId xmlns:p14="http://schemas.microsoft.com/office/powerpoint/2010/main" val="2457796145"/>
-      </p:ext>
-    </p:extLst>
-  </p:cSld>
-  <p:clrMapOvr>
-    <a:masterClrMapping/>
-  </p:clrMapOvr>
-</p:sld>
-</file>
-
-<file path=ppt/slides/slide4.xml><?xml version="1.0" encoding="utf-8"?>
-<p:sld xmlns:a="http://schemas.openxmlformats.org/drawingml/2006/main" xmlns:r="http://schemas.openxmlformats.org/officeDocument/2006/relationships" xmlns:p="http://schemas.openxmlformats.org/presentationml/2006/main">
-  <p:cSld>
-    <p:spTree>
-      <p:nvGrpSpPr>
-        <p:cNvPr id="1" name=""/>
-        <p:cNvGrpSpPr/>
-        <p:nvPr/>
-      </p:nvGrpSpPr>
-      <p:grpSpPr>
-        <a:xfrm>
-          <a:off x="0" y="0"/>
-          <a:ext cx="0" cy="0"/>
-          <a:chOff x="0" y="0"/>
-          <a:chExt cx="0" cy="0"/>
-        </a:xfrm>
-      </p:grpSpPr>
-      <p:sp>
-        <p:nvSpPr>
-          <p:cNvPr id="2" name="Title 1"/>
-          <p:cNvSpPr>
-            <a:spLocks noGrp="1"/>
-          </p:cNvSpPr>
-          <p:nvPr>
-            <p:ph type="title"/>
-          </p:nvPr>
-        </p:nvSpPr>
-        <p:spPr/>
-        <p:txBody>
-          <a:bodyPr/>
-          <a:lstStyle/>
-          <a:p>
-            <a:r>
-              <a:rPr lang="en-US" dirty="0" smtClean="0"/>
-              <a:t>DevOps Basics</a:t>
-            </a:r>
-            <a:endParaRPr lang="en-US" dirty="0"/>
-          </a:p>
-        </p:txBody>
-      </p:sp>
-      <p:sp>
-        <p:nvSpPr>
-          <p:cNvPr id="3" name="Text Placeholder 2"/>
-          <p:cNvSpPr>
-            <a:spLocks noGrp="1"/>
-          </p:cNvSpPr>
-          <p:nvPr>
-            <p:ph type="body" sz="quarter" idx="13"/>
-          </p:nvPr>
-        </p:nvSpPr>
-        <p:spPr>
-          <a:xfrm>
-            <a:off x="857739" y="1600201"/>
-            <a:ext cx="10160000" cy="2971799"/>
-          </a:xfrm>
-        </p:spPr>
-        <p:txBody>
-          <a:bodyPr>
-            <a:normAutofit/>
-          </a:bodyPr>
-          <a:lstStyle/>
-          <a:p>
-            <a:r>
-              <a:rPr lang="en-US" dirty="0"/>
-              <a:t>Definition of DevOps:</a:t>
-            </a:r>
-          </a:p>
-          <a:p>
-            <a:pPr lvl="1"/>
-            <a:r>
-              <a:rPr lang="en-US" dirty="0"/>
-              <a:t>“DevOps is a set of practices intended to reduce the time between committing a change to a system and the change being placed into normal production, while ensuring high quality”</a:t>
-            </a:r>
-          </a:p>
-          <a:p>
-            <a:endParaRPr lang="en-US" dirty="0"/>
-          </a:p>
-          <a:p>
-            <a:r>
-              <a:rPr lang="en-US" dirty="0"/>
-              <a:t>Implications of this definition</a:t>
-            </a:r>
-          </a:p>
-          <a:p>
-            <a:pPr lvl="1"/>
-            <a:r>
-              <a:rPr lang="en-US" dirty="0"/>
-              <a:t>Practices and tools</a:t>
-            </a:r>
-          </a:p>
-          <a:p>
-            <a:pPr lvl="1"/>
-            <a:r>
-              <a:rPr lang="en-US" dirty="0"/>
-              <a:t>Do not restricted scope of DevOps to testing and development </a:t>
-            </a:r>
-          </a:p>
-          <a:p>
-            <a:endParaRPr lang="en-US" dirty="0"/>
-          </a:p>
-        </p:txBody>
-      </p:sp>
-      <p:sp>
-        <p:nvSpPr>
-          <p:cNvPr id="4" name="Text Placeholder 3"/>
-          <p:cNvSpPr>
-            <a:spLocks noGrp="1"/>
-          </p:cNvSpPr>
-          <p:nvPr>
-            <p:ph type="body" sz="quarter" idx="14"/>
-          </p:nvPr>
-        </p:nvSpPr>
-        <p:spPr/>
-        <p:txBody>
-          <a:bodyPr/>
-          <a:lstStyle/>
-          <a:p>
-            <a:r>
-              <a:rPr lang="en-US" dirty="0" smtClean="0"/>
-              <a:t>Introduction Contd..</a:t>
-            </a:r>
-            <a:endParaRPr lang="en-US" dirty="0"/>
-          </a:p>
-        </p:txBody>
-      </p:sp>
-    </p:spTree>
-    <p:extLst>
-      <p:ext uri="{BB962C8B-B14F-4D97-AF65-F5344CB8AC3E}">
-        <p14:creationId xmlns:p14="http://schemas.microsoft.com/office/powerpoint/2010/main" val="1008182945"/>
-      </p:ext>
-    </p:extLst>
-  </p:cSld>
-  <p:clrMapOvr>
-    <a:masterClrMapping/>
-  </p:clrMapOvr>
-</p:sld>
-</file>
-
-<file path=ppt/slides/slide5.xml><?xml version="1.0" encoding="utf-8"?>
-<p:sld xmlns:a="http://schemas.openxmlformats.org/drawingml/2006/main" xmlns:r="http://schemas.openxmlformats.org/officeDocument/2006/relationships" xmlns:p="http://schemas.openxmlformats.org/presentationml/2006/main">
-  <p:cSld>
-    <p:spTree>
-      <p:nvGrpSpPr>
-        <p:cNvPr id="1" name=""/>
-        <p:cNvGrpSpPr/>
-        <p:nvPr/>
-      </p:nvGrpSpPr>
-      <p:grpSpPr>
-        <a:xfrm>
-          <a:off x="0" y="0"/>
-          <a:ext cx="0" cy="0"/>
-          <a:chOff x="0" y="0"/>
-          <a:chExt cx="0" cy="0"/>
-        </a:xfrm>
-      </p:grpSpPr>
-      <p:sp>
-        <p:nvSpPr>
-          <p:cNvPr id="2" name="Title 1"/>
-          <p:cNvSpPr>
-            <a:spLocks noGrp="1"/>
-          </p:cNvSpPr>
-          <p:nvPr>
-            <p:ph type="title"/>
-          </p:nvPr>
-        </p:nvSpPr>
-        <p:spPr/>
-        <p:txBody>
-          <a:bodyPr/>
-          <a:lstStyle/>
-          <a:p>
-            <a:r>
-              <a:rPr lang="en-US" dirty="0" smtClean="0"/>
-              <a:t>DevOps Basics </a:t>
-            </a:r>
-            <a:endParaRPr lang="en-US" dirty="0"/>
-          </a:p>
-        </p:txBody>
-      </p:sp>
-      <p:sp>
-        <p:nvSpPr>
-          <p:cNvPr id="3" name="Text Placeholder 2"/>
-          <p:cNvSpPr>
-            <a:spLocks noGrp="1"/>
-          </p:cNvSpPr>
-          <p:nvPr>
-            <p:ph type="body" sz="quarter" idx="13"/>
-          </p:nvPr>
-        </p:nvSpPr>
-        <p:spPr/>
-        <p:txBody>
-          <a:bodyPr/>
-          <a:lstStyle/>
-          <a:p>
-            <a:r>
-              <a:rPr lang="en-US" dirty="0"/>
-              <a:t>Developer </a:t>
-            </a:r>
-            <a:r>
-              <a:rPr lang="en-US" dirty="0" smtClean="0"/>
-              <a:t>:- </a:t>
-            </a:r>
-            <a:r>
-              <a:rPr lang="en-US" dirty="0"/>
-              <a:t>Writing Code</a:t>
-            </a:r>
-          </a:p>
-          <a:p>
-            <a:endParaRPr lang="en-US" dirty="0"/>
-          </a:p>
-          <a:p>
-            <a:r>
-              <a:rPr lang="en-US" dirty="0" smtClean="0"/>
-              <a:t>Quality </a:t>
-            </a:r>
-            <a:r>
-              <a:rPr lang="en-US" dirty="0"/>
-              <a:t>Assurance :- Testing </a:t>
-            </a:r>
-          </a:p>
-          <a:p>
-            <a:endParaRPr lang="en-US" dirty="0"/>
-          </a:p>
-          <a:p>
-            <a:r>
-              <a:rPr lang="en-US" dirty="0"/>
-              <a:t>O</a:t>
-            </a:r>
-            <a:r>
-              <a:rPr lang="en-US" dirty="0" smtClean="0"/>
-              <a:t>perations </a:t>
-            </a:r>
-            <a:r>
-              <a:rPr lang="en-US" dirty="0" smtClean="0"/>
-              <a:t>personnel :- </a:t>
-            </a:r>
-            <a:r>
-              <a:rPr lang="en-US" dirty="0"/>
-              <a:t>Deploy </a:t>
-            </a:r>
-          </a:p>
-          <a:p>
-            <a:endParaRPr lang="en-US" dirty="0"/>
-          </a:p>
-        </p:txBody>
-      </p:sp>
-      <p:sp>
-        <p:nvSpPr>
-          <p:cNvPr id="4" name="Text Placeholder 3"/>
-          <p:cNvSpPr>
-            <a:spLocks noGrp="1"/>
-          </p:cNvSpPr>
-          <p:nvPr>
-            <p:ph type="body" sz="quarter" idx="14"/>
-          </p:nvPr>
-        </p:nvSpPr>
-        <p:spPr/>
-        <p:txBody>
-          <a:bodyPr/>
-          <a:lstStyle/>
-          <a:p>
-            <a:r>
-              <a:rPr lang="en-US" dirty="0"/>
-              <a:t>Need </a:t>
-            </a:r>
-            <a:r>
-              <a:rPr lang="en-US" dirty="0" smtClean="0"/>
-              <a:t>for </a:t>
-            </a:r>
-            <a:r>
-              <a:rPr lang="en-US" dirty="0"/>
-              <a:t>DevOps </a:t>
-            </a:r>
-          </a:p>
-        </p:txBody>
-      </p:sp>
-      <p:graphicFrame>
-        <p:nvGraphicFramePr>
-          <p:cNvPr id="5" name="Content Placeholder 5"/>
-          <p:cNvGraphicFramePr>
-            <a:graphicFrameLocks/>
-          </p:cNvGraphicFramePr>
-          <p:nvPr>
-            <p:extLst>
-              <p:ext uri="{D42A27DB-BD31-4B8C-83A1-F6EECF244321}">
-                <p14:modId xmlns:p14="http://schemas.microsoft.com/office/powerpoint/2010/main" val="2592704613"/>
-              </p:ext>
-            </p:extLst>
-          </p:nvPr>
-        </p:nvGraphicFramePr>
-        <p:xfrm>
-          <a:off x="5181600" y="2819400"/>
-          <a:ext cx="5164541" cy="3738562"/>
-        </p:xfrm>
-        <a:graphic>
-          <a:graphicData uri="http://schemas.openxmlformats.org/drawingml/2006/diagram">
-            <dgm:relIds xmlns:dgm="http://schemas.openxmlformats.org/drawingml/2006/diagram" xmlns:r="http://schemas.openxmlformats.org/officeDocument/2006/relationships" r:dm="rId2" r:lo="rId3" r:qs="rId4" r:cs="rId5"/>
-          </a:graphicData>
-        </a:graphic>
-      </p:graphicFrame>
-    </p:spTree>
-    <p:extLst>
-      <p:ext uri="{BB962C8B-B14F-4D97-AF65-F5344CB8AC3E}">
-        <p14:creationId xmlns:p14="http://schemas.microsoft.com/office/powerpoint/2010/main" val="2275560999"/>
-      </p:ext>
-    </p:extLst>
-  </p:cSld>
-  <p:clrMapOvr>
-    <a:masterClrMapping/>
-  </p:clrMapOvr>
-</p:sld>
-</file>
-
-<file path=ppt/slides/slide6.xml><?xml version="1.0" encoding="utf-8"?>
-<p:sld xmlns:a="http://schemas.openxmlformats.org/drawingml/2006/main" xmlns:r="http://schemas.openxmlformats.org/officeDocument/2006/relationships" xmlns:p="http://schemas.openxmlformats.org/presentationml/2006/main">
-  <p:cSld>
-    <p:spTree>
-      <p:nvGrpSpPr>
-        <p:cNvPr id="1" name=""/>
-        <p:cNvGrpSpPr/>
-        <p:nvPr/>
-      </p:nvGrpSpPr>
-      <p:grpSpPr>
-        <a:xfrm>
-          <a:off x="0" y="0"/>
-          <a:ext cx="0" cy="0"/>
-          <a:chOff x="0" y="0"/>
-          <a:chExt cx="0" cy="0"/>
-        </a:xfrm>
-      </p:grpSpPr>
-      <p:sp>
-        <p:nvSpPr>
-          <p:cNvPr id="2" name="Title 1"/>
-          <p:cNvSpPr>
-            <a:spLocks noGrp="1"/>
-          </p:cNvSpPr>
-          <p:nvPr>
-            <p:ph type="title"/>
-          </p:nvPr>
-        </p:nvSpPr>
-        <p:spPr/>
-        <p:txBody>
-          <a:bodyPr/>
-          <a:lstStyle/>
-          <a:p>
-            <a:r>
-              <a:rPr lang="en-US" dirty="0" smtClean="0"/>
-              <a:t>DevOps Basics</a:t>
-            </a:r>
-            <a:endParaRPr lang="en-US" dirty="0"/>
-          </a:p>
-        </p:txBody>
-      </p:sp>
-      <p:sp>
-        <p:nvSpPr>
-          <p:cNvPr id="4" name="Text Placeholder 3"/>
-          <p:cNvSpPr>
-            <a:spLocks noGrp="1"/>
-          </p:cNvSpPr>
-          <p:nvPr>
-            <p:ph type="body" sz="quarter" idx="14"/>
-          </p:nvPr>
-        </p:nvSpPr>
-        <p:spPr/>
-        <p:txBody>
-          <a:bodyPr/>
-          <a:lstStyle/>
-          <a:p>
-            <a:r>
-              <a:rPr lang="en-US" dirty="0" smtClean="0"/>
-              <a:t>Need for DevOps Contd..</a:t>
-            </a:r>
-            <a:endParaRPr lang="en-US" dirty="0"/>
-          </a:p>
-        </p:txBody>
-      </p:sp>
-      <p:graphicFrame>
-        <p:nvGraphicFramePr>
-          <p:cNvPr id="9" name="Content Placeholder 5"/>
-          <p:cNvGraphicFramePr>
-            <a:graphicFrameLocks/>
-          </p:cNvGraphicFramePr>
-          <p:nvPr>
-            <p:extLst>
-              <p:ext uri="{D42A27DB-BD31-4B8C-83A1-F6EECF244321}">
-                <p14:modId xmlns:p14="http://schemas.microsoft.com/office/powerpoint/2010/main" val="4045946368"/>
-              </p:ext>
-            </p:extLst>
-          </p:nvPr>
-        </p:nvGraphicFramePr>
-        <p:xfrm>
-          <a:off x="8342572" y="1623218"/>
-          <a:ext cx="3282950" cy="4351338"/>
-        </p:xfrm>
-        <a:graphic>
-          <a:graphicData uri="http://schemas.openxmlformats.org/drawingml/2006/diagram">
-            <dgm:relIds xmlns:dgm="http://schemas.openxmlformats.org/drawingml/2006/diagram" xmlns:r="http://schemas.openxmlformats.org/officeDocument/2006/relationships" r:dm="rId2" r:lo="rId3" r:qs="rId4" r:cs="rId5"/>
-          </a:graphicData>
-        </a:graphic>
-      </p:graphicFrame>
-      <p:graphicFrame>
-        <p:nvGraphicFramePr>
-          <p:cNvPr id="10" name="Content Placeholder 4"/>
-          <p:cNvGraphicFramePr>
-            <a:graphicFrameLocks/>
-          </p:cNvGraphicFramePr>
-          <p:nvPr>
-            <p:extLst>
-              <p:ext uri="{D42A27DB-BD31-4B8C-83A1-F6EECF244321}">
-                <p14:modId xmlns:p14="http://schemas.microsoft.com/office/powerpoint/2010/main" val="4233279266"/>
-              </p:ext>
-            </p:extLst>
-          </p:nvPr>
-        </p:nvGraphicFramePr>
-        <p:xfrm>
-          <a:off x="122829" y="1555750"/>
-          <a:ext cx="8194343" cy="4486275"/>
-        </p:xfrm>
-        <a:graphic>
-          <a:graphicData uri="http://schemas.openxmlformats.org/drawingml/2006/diagram">
-            <dgm:relIds xmlns:dgm="http://schemas.openxmlformats.org/drawingml/2006/diagram" xmlns:r="http://schemas.openxmlformats.org/officeDocument/2006/relationships" r:dm="rId7" r:lo="rId8" r:qs="rId9" r:cs="rId10"/>
-          </a:graphicData>
-        </a:graphic>
-      </p:graphicFrame>
-    </p:spTree>
-    <p:extLst>
-      <p:ext uri="{BB962C8B-B14F-4D97-AF65-F5344CB8AC3E}">
-        <p14:creationId xmlns:p14="http://schemas.microsoft.com/office/powerpoint/2010/main" val="2387696097"/>
-      </p:ext>
-    </p:extLst>
-  </p:cSld>
-  <p:clrMapOvr>
-    <a:masterClrMapping/>
-  </p:clrMapOvr>
-</p:sld>
-</file>
-
-<file path=ppt/slides/slide7.xml><?xml version="1.0" encoding="utf-8"?>
-<p:sld xmlns:a="http://schemas.openxmlformats.org/drawingml/2006/main" xmlns:r="http://schemas.openxmlformats.org/officeDocument/2006/relationships" xmlns:p="http://schemas.openxmlformats.org/presentationml/2006/main">
-  <p:cSld>
-    <p:spTree>
-      <p:nvGrpSpPr>
-        <p:cNvPr id="1" name=""/>
-        <p:cNvGrpSpPr/>
-        <p:nvPr/>
-      </p:nvGrpSpPr>
-      <p:grpSpPr>
-        <a:xfrm>
-          <a:off x="0" y="0"/>
-          <a:ext cx="0" cy="0"/>
-          <a:chOff x="0" y="0"/>
-          <a:chExt cx="0" cy="0"/>
-        </a:xfrm>
-      </p:grpSpPr>
-      <p:sp>
-        <p:nvSpPr>
-          <p:cNvPr id="2" name="Title 1"/>
-          <p:cNvSpPr>
-            <a:spLocks noGrp="1"/>
-          </p:cNvSpPr>
-          <p:nvPr>
-            <p:ph type="title"/>
-          </p:nvPr>
-        </p:nvSpPr>
-        <p:spPr/>
-        <p:txBody>
-          <a:bodyPr/>
-          <a:lstStyle/>
-          <a:p>
-            <a:r>
-              <a:rPr lang="en-US" dirty="0"/>
-              <a:t>DevOps Basics</a:t>
-            </a:r>
-          </a:p>
-        </p:txBody>
-      </p:sp>
-      <p:sp>
-        <p:nvSpPr>
-          <p:cNvPr id="4" name="Text Placeholder 3"/>
-          <p:cNvSpPr>
-            <a:spLocks noGrp="1"/>
-          </p:cNvSpPr>
-          <p:nvPr>
-            <p:ph type="body" sz="quarter" idx="14"/>
-          </p:nvPr>
-        </p:nvSpPr>
-        <p:spPr/>
-        <p:txBody>
-          <a:bodyPr/>
-          <a:lstStyle/>
-          <a:p>
-            <a:r>
-              <a:rPr lang="en-US" dirty="0"/>
-              <a:t>Need for DevOps Contd</a:t>
-            </a:r>
-            <a:r>
-              <a:rPr lang="en-US" dirty="0" smtClean="0"/>
-              <a:t>..</a:t>
-            </a:r>
-            <a:endParaRPr lang="en-US" dirty="0"/>
-          </a:p>
-        </p:txBody>
-      </p:sp>
-      <p:graphicFrame>
-        <p:nvGraphicFramePr>
-          <p:cNvPr id="5" name="Content Placeholder 5"/>
-          <p:cNvGraphicFramePr>
-            <a:graphicFrameLocks/>
-          </p:cNvGraphicFramePr>
-          <p:nvPr>
-            <p:extLst>
-              <p:ext uri="{D42A27DB-BD31-4B8C-83A1-F6EECF244321}">
-                <p14:modId xmlns:p14="http://schemas.microsoft.com/office/powerpoint/2010/main" val="2659680095"/>
-              </p:ext>
-            </p:extLst>
-          </p:nvPr>
-        </p:nvGraphicFramePr>
-        <p:xfrm>
-          <a:off x="6461078" y="1690688"/>
-          <a:ext cx="5181600" cy="4351338"/>
-        </p:xfrm>
-        <a:graphic>
-          <a:graphicData uri="http://schemas.openxmlformats.org/drawingml/2006/diagram">
-            <dgm:relIds xmlns:dgm="http://schemas.openxmlformats.org/drawingml/2006/diagram" xmlns:r="http://schemas.openxmlformats.org/officeDocument/2006/relationships" r:dm="rId2" r:lo="rId3" r:qs="rId4" r:cs="rId5"/>
-          </a:graphicData>
-        </a:graphic>
-      </p:graphicFrame>
-      <p:graphicFrame>
-        <p:nvGraphicFramePr>
-          <p:cNvPr id="6" name="Content Placeholder 6"/>
-          <p:cNvGraphicFramePr>
-            <a:graphicFrameLocks/>
-          </p:cNvGraphicFramePr>
-          <p:nvPr>
-            <p:extLst>
-              <p:ext uri="{D42A27DB-BD31-4B8C-83A1-F6EECF244321}">
-                <p14:modId xmlns:p14="http://schemas.microsoft.com/office/powerpoint/2010/main" val="162877414"/>
-              </p:ext>
-            </p:extLst>
-          </p:nvPr>
-        </p:nvGraphicFramePr>
-        <p:xfrm>
-          <a:off x="914400" y="1690688"/>
-          <a:ext cx="5257800" cy="4351338"/>
-        </p:xfrm>
-        <a:graphic>
-          <a:graphicData uri="http://schemas.openxmlformats.org/drawingml/2006/diagram">
-            <dgm:relIds xmlns:dgm="http://schemas.openxmlformats.org/drawingml/2006/diagram" xmlns:r="http://schemas.openxmlformats.org/officeDocument/2006/relationships" r:dm="rId7" r:lo="rId8" r:qs="rId9" r:cs="rId10"/>
-          </a:graphicData>
-        </a:graphic>
-      </p:graphicFrame>
-    </p:spTree>
-    <p:extLst>
-      <p:ext uri="{BB962C8B-B14F-4D97-AF65-F5344CB8AC3E}">
-        <p14:creationId xmlns:p14="http://schemas.microsoft.com/office/powerpoint/2010/main" val="1461455547"/>
-      </p:ext>
-    </p:extLst>
-  </p:cSld>
-  <p:clrMapOvr>
-    <a:masterClrMapping/>
-  </p:clrMapOvr>
-</p:sld>
-</file>
-
-<file path=ppt/slides/slide8.xml><?xml version="1.0" encoding="utf-8"?>
-<p:sld xmlns:a="http://schemas.openxmlformats.org/drawingml/2006/main" xmlns:r="http://schemas.openxmlformats.org/officeDocument/2006/relationships" xmlns:p="http://schemas.openxmlformats.org/presentationml/2006/main">
-  <p:cSld>
-    <p:spTree>
-      <p:nvGrpSpPr>
-        <p:cNvPr id="1" name=""/>
-        <p:cNvGrpSpPr/>
-        <p:nvPr/>
-      </p:nvGrpSpPr>
-      <p:grpSpPr>
-        <a:xfrm>
-          <a:off x="0" y="0"/>
-          <a:ext cx="0" cy="0"/>
-          <a:chOff x="0" y="0"/>
-          <a:chExt cx="0" cy="0"/>
-        </a:xfrm>
-      </p:grpSpPr>
-      <p:sp>
-        <p:nvSpPr>
-          <p:cNvPr id="2" name="Title 1"/>
-          <p:cNvSpPr>
-            <a:spLocks noGrp="1"/>
-          </p:cNvSpPr>
-          <p:nvPr>
-            <p:ph type="title"/>
-          </p:nvPr>
-        </p:nvSpPr>
-        <p:spPr/>
-        <p:txBody>
-          <a:bodyPr/>
-          <a:lstStyle/>
-          <a:p>
-            <a:r>
-              <a:rPr lang="en-US" dirty="0"/>
-              <a:t>DevOps Basics</a:t>
-            </a:r>
-          </a:p>
-        </p:txBody>
-      </p:sp>
-      <p:sp>
-        <p:nvSpPr>
-          <p:cNvPr id="4" name="Text Placeholder 3"/>
-          <p:cNvSpPr>
-            <a:spLocks noGrp="1"/>
-          </p:cNvSpPr>
-          <p:nvPr>
-            <p:ph type="body" sz="quarter" idx="14"/>
-          </p:nvPr>
-        </p:nvSpPr>
-        <p:spPr/>
-        <p:txBody>
-          <a:bodyPr/>
-          <a:lstStyle/>
-          <a:p>
-            <a:r>
-              <a:rPr lang="en-US" dirty="0"/>
-              <a:t>Need for DevOps Contd</a:t>
-            </a:r>
-            <a:r>
-              <a:rPr lang="en-US" dirty="0" smtClean="0"/>
-              <a:t>..</a:t>
-            </a:r>
-            <a:endParaRPr lang="en-US" dirty="0"/>
-          </a:p>
-        </p:txBody>
-      </p:sp>
-      <p:pic>
-        <p:nvPicPr>
-          <p:cNvPr id="3" name="Picture 2"/>
-          <p:cNvPicPr>
-            <a:picLocks noChangeAspect="1"/>
-          </p:cNvPicPr>
-          <p:nvPr/>
-        </p:nvPicPr>
-        <p:blipFill>
-          <a:blip r:embed="rId2"/>
-          <a:stretch>
-            <a:fillRect/>
-          </a:stretch>
-        </p:blipFill>
-        <p:spPr>
-          <a:xfrm>
-            <a:off x="2057400" y="1756356"/>
-            <a:ext cx="7696200" cy="4071937"/>
-          </a:xfrm>
-          <a:prstGeom prst="rect">
-            <a:avLst/>
-          </a:prstGeom>
-        </p:spPr>
-      </p:pic>
-      <p:sp>
-        <p:nvSpPr>
-          <p:cNvPr id="7" name="TextBox 6"/>
-          <p:cNvSpPr txBox="1"/>
-          <p:nvPr/>
-        </p:nvSpPr>
-        <p:spPr>
-          <a:xfrm>
-            <a:off x="8077200" y="5877084"/>
-            <a:ext cx="2819400" cy="338554"/>
-          </a:xfrm>
-          <a:prstGeom prst="rect">
-            <a:avLst/>
-          </a:prstGeom>
-          <a:noFill/>
-        </p:spPr>
-        <p:txBody>
-          <a:bodyPr wrap="square" rtlCol="0">
-            <a:spAutoFit/>
-          </a:bodyPr>
-          <a:lstStyle/>
-          <a:p>
-            <a:r>
-              <a:rPr lang="en-US" sz="1600" dirty="0">
-                <a:latin typeface="Helvetica" panose="020B0604020202020204" pitchFamily="34" charset="0"/>
-                <a:cs typeface="Helvetica" panose="020B0604020202020204" pitchFamily="34" charset="0"/>
-              </a:rPr>
-              <a:t>https://in.pinterest.com/</a:t>
-            </a:r>
-          </a:p>
-        </p:txBody>
-      </p:sp>
-    </p:spTree>
-    <p:extLst>
-      <p:ext uri="{BB962C8B-B14F-4D97-AF65-F5344CB8AC3E}">
-        <p14:creationId xmlns:p14="http://schemas.microsoft.com/office/powerpoint/2010/main" val="3394443243"/>
-      </p:ext>
-    </p:extLst>
-  </p:cSld>
-  <p:clrMapOvr>
-    <a:masterClrMapping/>
-  </p:clrMapOvr>
-</p:sld>
-</file>
-
-<file path=ppt/slides/slide9.xml><?xml version="1.0" encoding="utf-8"?>
-<p:sld xmlns:a="http://schemas.openxmlformats.org/drawingml/2006/main" xmlns:r="http://schemas.openxmlformats.org/officeDocument/2006/relationships" xmlns:p="http://schemas.openxmlformats.org/presentationml/2006/main">
-  <p:cSld>
-    <p:spTree>
-      <p:nvGrpSpPr>
-        <p:cNvPr id="1" name=""/>
-        <p:cNvGrpSpPr/>
-        <p:nvPr/>
-      </p:nvGrpSpPr>
-      <p:grpSpPr>
-        <a:xfrm>
-          <a:off x="0" y="0"/>
-          <a:ext cx="0" cy="0"/>
-          <a:chOff x="0" y="0"/>
-          <a:chExt cx="0" cy="0"/>
-        </a:xfrm>
-      </p:grpSpPr>
-      <p:sp>
-        <p:nvSpPr>
-          <p:cNvPr id="2" name="Title 1"/>
-          <p:cNvSpPr>
-            <a:spLocks noGrp="1"/>
-          </p:cNvSpPr>
-          <p:nvPr>
-            <p:ph type="title"/>
-          </p:nvPr>
-        </p:nvSpPr>
-        <p:spPr/>
-        <p:txBody>
-          <a:bodyPr/>
-          <a:lstStyle/>
-          <a:p>
-            <a:r>
-              <a:rPr lang="en-US" dirty="0" smtClean="0"/>
-              <a:t>DevOps Basics</a:t>
-            </a:r>
-            <a:endParaRPr lang="en-US" dirty="0"/>
-          </a:p>
-        </p:txBody>
-      </p:sp>
-      <p:sp>
-        <p:nvSpPr>
-          <p:cNvPr id="3" name="Text Placeholder 2"/>
-          <p:cNvSpPr>
-            <a:spLocks noGrp="1"/>
-          </p:cNvSpPr>
-          <p:nvPr>
-            <p:ph type="body" sz="quarter" idx="13"/>
-          </p:nvPr>
-        </p:nvSpPr>
-        <p:spPr>
-          <a:xfrm>
-            <a:off x="857739" y="1600201"/>
-            <a:ext cx="10160000" cy="3962399"/>
-          </a:xfrm>
-        </p:spPr>
-        <p:txBody>
-          <a:bodyPr>
-            <a:normAutofit fontScale="92500" lnSpcReduction="10000"/>
-          </a:bodyPr>
-          <a:lstStyle/>
-          <a:p>
-            <a:r>
-              <a:rPr lang="en-US" dirty="0" smtClean="0"/>
-              <a:t>Waterfall Model</a:t>
-            </a:r>
-          </a:p>
-          <a:p>
-            <a:r>
-              <a:rPr lang="en-US" dirty="0" smtClean="0"/>
-              <a:t>Dominated Project Management Until 2001</a:t>
-            </a:r>
-          </a:p>
-          <a:p>
-            <a:endParaRPr lang="en-US" dirty="0" smtClean="0"/>
-          </a:p>
-          <a:p>
-            <a:r>
-              <a:rPr lang="en-US" dirty="0" smtClean="0"/>
-              <a:t>Still in Use :</a:t>
-            </a:r>
-          </a:p>
-          <a:p>
-            <a:pPr lvl="1"/>
-            <a:r>
-              <a:rPr lang="en-US" dirty="0" smtClean="0"/>
-              <a:t>Disciplined Approach</a:t>
-            </a:r>
-          </a:p>
-          <a:p>
-            <a:pPr lvl="1"/>
-            <a:r>
-              <a:rPr lang="en-US" dirty="0" smtClean="0"/>
-              <a:t>Thorough Scoping</a:t>
-            </a:r>
-          </a:p>
-          <a:p>
-            <a:pPr lvl="1"/>
-            <a:r>
-              <a:rPr lang="en-US" dirty="0" smtClean="0"/>
-              <a:t>Clear Stages</a:t>
-            </a:r>
-          </a:p>
-          <a:p>
-            <a:pPr lvl="1"/>
-            <a:r>
-              <a:rPr lang="en-US" dirty="0" smtClean="0"/>
-              <a:t>Concrete Deadlines</a:t>
-            </a:r>
-          </a:p>
-          <a:p>
-            <a:endParaRPr lang="en-US" dirty="0" smtClean="0"/>
-          </a:p>
-          <a:p>
-            <a:r>
-              <a:rPr lang="en-US" dirty="0" smtClean="0"/>
-              <a:t>Disadvantages:</a:t>
-            </a:r>
-          </a:p>
-          <a:p>
-            <a:pPr lvl="1"/>
-            <a:r>
-              <a:rPr lang="en-US" dirty="0" smtClean="0"/>
-              <a:t>Sequential </a:t>
-            </a:r>
-          </a:p>
-          <a:p>
-            <a:pPr lvl="1"/>
-            <a:r>
-              <a:rPr lang="en-US" dirty="0" smtClean="0"/>
-              <a:t>Inflexible</a:t>
-            </a:r>
-          </a:p>
-          <a:p>
-            <a:pPr lvl="1"/>
-            <a:r>
-              <a:rPr lang="en-US" dirty="0" smtClean="0"/>
-              <a:t>Assumptions</a:t>
-            </a:r>
-            <a:endParaRPr lang="en-US" dirty="0"/>
-          </a:p>
-        </p:txBody>
-      </p:sp>
-      <p:sp>
-        <p:nvSpPr>
-          <p:cNvPr id="4" name="Text Placeholder 3"/>
-          <p:cNvSpPr>
-            <a:spLocks noGrp="1"/>
-          </p:cNvSpPr>
-          <p:nvPr>
-            <p:ph type="body" sz="quarter" idx="14"/>
-          </p:nvPr>
-        </p:nvSpPr>
-        <p:spPr/>
-        <p:txBody>
-          <a:bodyPr/>
-          <a:lstStyle/>
-          <a:p>
-            <a:r>
-              <a:rPr lang="en-US" dirty="0" smtClean="0"/>
-              <a:t>Need for DevOps Contd..</a:t>
-            </a:r>
-            <a:endParaRPr lang="en-US" dirty="0"/>
-          </a:p>
-        </p:txBody>
-      </p:sp>
-      <p:sp>
-        <p:nvSpPr>
-          <p:cNvPr id="5" name="TextBox 4"/>
-          <p:cNvSpPr txBox="1"/>
-          <p:nvPr/>
-        </p:nvSpPr>
-        <p:spPr>
-          <a:xfrm>
-            <a:off x="3962400" y="5105400"/>
-            <a:ext cx="4876800" cy="369332"/>
-          </a:xfrm>
-          <a:prstGeom prst="rect">
-            <a:avLst/>
-          </a:prstGeom>
-          <a:noFill/>
-        </p:spPr>
-        <p:txBody>
-          <a:bodyPr wrap="square" rtlCol="0">
-            <a:spAutoFit/>
-          </a:bodyPr>
-          <a:lstStyle/>
-          <a:p>
-            <a:r>
-              <a:rPr lang="en-US" b="1" dirty="0">
-                <a:solidFill>
-                  <a:srgbClr val="FF0000"/>
-                </a:solidFill>
-                <a:latin typeface="Helvetica" panose="020B0604020202020204" pitchFamily="34" charset="0"/>
-                <a:cs typeface="Helvetica" panose="020B0604020202020204" pitchFamily="34" charset="0"/>
-              </a:rPr>
-              <a:t>We </a:t>
-            </a:r>
-            <a:r>
-              <a:rPr lang="en-US" b="1" dirty="0" smtClean="0">
-                <a:solidFill>
-                  <a:srgbClr val="FF0000"/>
-                </a:solidFill>
-                <a:latin typeface="Helvetica" panose="020B0604020202020204" pitchFamily="34" charset="0"/>
-                <a:cs typeface="Helvetica" panose="020B0604020202020204" pitchFamily="34" charset="0"/>
-              </a:rPr>
-              <a:t>are </a:t>
-            </a:r>
-            <a:r>
-              <a:rPr lang="en-US" b="1" dirty="0">
-                <a:solidFill>
-                  <a:srgbClr val="FF0000"/>
-                </a:solidFill>
-                <a:latin typeface="Helvetica" panose="020B0604020202020204" pitchFamily="34" charset="0"/>
-                <a:cs typeface="Helvetica" panose="020B0604020202020204" pitchFamily="34" charset="0"/>
-              </a:rPr>
-              <a:t>loosing Time to market </a:t>
-            </a:r>
-          </a:p>
-        </p:txBody>
-      </p:sp>
-    </p:spTree>
-    <p:extLst>
-      <p:ext uri="{BB962C8B-B14F-4D97-AF65-F5344CB8AC3E}">
-        <p14:creationId xmlns:p14="http://schemas.microsoft.com/office/powerpoint/2010/main" val="882684043"/>
       </p:ext>
     </p:extLst>
   </p:cSld>

</xml_diff>